<commit_message>
Week 3 Update last
</commit_message>
<xml_diff>
--- a/cohort 2026/template_MADIEGA_files/Energy_Supply_Systems_Aida.pptx
+++ b/cohort 2026/template_MADIEGA_files/Energy_Supply_Systems_Aida.pptx
@@ -5,7 +5,7 @@
     <p:sldMasterId id="2147483678" r:id="rId1"/>
   </p:sldMasterIdLst>
   <p:notesMasterIdLst>
-    <p:notesMasterId r:id="rId17"/>
+    <p:notesMasterId r:id="rId19"/>
   </p:notesMasterIdLst>
   <p:sldIdLst>
     <p:sldId id="256" r:id="rId2"/>
@@ -21,22 +21,24 @@
     <p:sldId id="298" r:id="rId12"/>
     <p:sldId id="301" r:id="rId13"/>
     <p:sldId id="302" r:id="rId14"/>
-    <p:sldId id="265" r:id="rId15"/>
-    <p:sldId id="303" r:id="rId16"/>
+    <p:sldId id="304" r:id="rId15"/>
+    <p:sldId id="305" r:id="rId16"/>
+    <p:sldId id="265" r:id="rId17"/>
+    <p:sldId id="303" r:id="rId18"/>
   </p:sldIdLst>
   <p:sldSz cx="9144000" cy="5143500" type="screen16x9"/>
   <p:notesSz cx="6858000" cy="9144000"/>
   <p:embeddedFontLst>
     <p:embeddedFont>
       <p:font typeface="Bebas Neue" panose="020B0606020202050201" pitchFamily="34" charset="0"/>
-      <p:regular r:id="rId18"/>
+      <p:regular r:id="rId20"/>
     </p:embeddedFont>
     <p:embeddedFont>
       <p:font typeface="Open Sans" panose="020B0606030504020204" pitchFamily="34" charset="0"/>
-      <p:regular r:id="rId19"/>
-      <p:bold r:id="rId20"/>
-      <p:italic r:id="rId21"/>
-      <p:boldItalic r:id="rId22"/>
+      <p:regular r:id="rId21"/>
+      <p:bold r:id="rId22"/>
+      <p:italic r:id="rId23"/>
+      <p:boldItalic r:id="rId24"/>
     </p:embeddedFont>
   </p:embeddedFontLst>
   <p:defaultTextStyle>
@@ -268,6 +270,11 @@
       </a:defRPr>
     </a:lvl9pPr>
   </p:defaultTextStyle>
+  <p:extLst>
+    <p:ext uri="{EFAFB233-063F-42B5-8137-9DF3F51BA10A}">
+      <p15:sldGuideLst xmlns:p15="http://schemas.microsoft.com/office/powerpoint/2012/main"/>
+    </p:ext>
+  </p:extLst>
 </p:presentation>
 </file>
 
@@ -1329,6 +1336,260 @@
   <p:cSld>
     <p:spTree>
       <p:nvGrpSpPr>
+        <p:cNvPr id="1" name="Shape 278">
+          <a:extLst>
+            <a:ext uri="{FF2B5EF4-FFF2-40B4-BE49-F238E27FC236}">
+              <a16:creationId xmlns:a16="http://schemas.microsoft.com/office/drawing/2014/main" id="{8509029C-61E8-5452-DC52-4D92D311F933}"/>
+            </a:ext>
+          </a:extLst>
+        </p:cNvPr>
+        <p:cNvGrpSpPr/>
+        <p:nvPr/>
+      </p:nvGrpSpPr>
+      <p:grpSpPr>
+        <a:xfrm>
+          <a:off x="0" y="0"/>
+          <a:ext cx="0" cy="0"/>
+          <a:chOff x="0" y="0"/>
+          <a:chExt cx="0" cy="0"/>
+        </a:xfrm>
+      </p:grpSpPr>
+      <p:sp>
+        <p:nvSpPr>
+          <p:cNvPr id="279" name="Google Shape;279;g1485a77ac1f_0_22:notes">
+            <a:extLst>
+              <a:ext uri="{FF2B5EF4-FFF2-40B4-BE49-F238E27FC236}">
+                <a16:creationId xmlns:a16="http://schemas.microsoft.com/office/drawing/2014/main" id="{FFF6C259-3A53-1D9C-1DC1-F3C554755916}"/>
+              </a:ext>
+            </a:extLst>
+          </p:cNvPr>
+          <p:cNvSpPr>
+            <a:spLocks noGrp="1" noRot="1" noChangeAspect="1"/>
+          </p:cNvSpPr>
+          <p:nvPr>
+            <p:ph type="sldImg" idx="2"/>
+          </p:nvPr>
+        </p:nvSpPr>
+        <p:spPr>
+          <a:xfrm>
+            <a:off x="381000" y="685800"/>
+            <a:ext cx="6096000" cy="3429000"/>
+          </a:xfrm>
+          <a:custGeom>
+            <a:avLst/>
+            <a:gdLst/>
+            <a:ahLst/>
+            <a:cxnLst/>
+            <a:rect l="l" t="t" r="r" b="b"/>
+            <a:pathLst>
+              <a:path w="120000" h="120000" extrusionOk="0">
+                <a:moveTo>
+                  <a:pt x="0" y="0"/>
+                </a:moveTo>
+                <a:lnTo>
+                  <a:pt x="120000" y="0"/>
+                </a:lnTo>
+                <a:lnTo>
+                  <a:pt x="120000" y="120000"/>
+                </a:lnTo>
+                <a:lnTo>
+                  <a:pt x="0" y="120000"/>
+                </a:lnTo>
+                <a:close/>
+              </a:path>
+            </a:pathLst>
+          </a:custGeom>
+        </p:spPr>
+      </p:sp>
+      <p:sp>
+        <p:nvSpPr>
+          <p:cNvPr id="280" name="Google Shape;280;g1485a77ac1f_0_22:notes">
+            <a:extLst>
+              <a:ext uri="{FF2B5EF4-FFF2-40B4-BE49-F238E27FC236}">
+                <a16:creationId xmlns:a16="http://schemas.microsoft.com/office/drawing/2014/main" id="{542D8EBE-1E4C-6790-A10E-8D308F50DFE0}"/>
+              </a:ext>
+            </a:extLst>
+          </p:cNvPr>
+          <p:cNvSpPr txBox="1">
+            <a:spLocks noGrp="1"/>
+          </p:cNvSpPr>
+          <p:nvPr>
+            <p:ph type="body" idx="1"/>
+          </p:nvPr>
+        </p:nvSpPr>
+        <p:spPr>
+          <a:xfrm>
+            <a:off x="685800" y="4343400"/>
+            <a:ext cx="5486400" cy="4114800"/>
+          </a:xfrm>
+          <a:prstGeom prst="rect">
+            <a:avLst/>
+          </a:prstGeom>
+        </p:spPr>
+        <p:txBody>
+          <a:bodyPr spcFirstLastPara="1" wrap="square" lIns="91425" tIns="91425" rIns="91425" bIns="91425" anchor="t" anchorCtr="0">
+            <a:noAutofit/>
+          </a:bodyPr>
+          <a:lstStyle/>
+          <a:p>
+            <a:pPr marL="0" lvl="0" indent="0" algn="l" rtl="0">
+              <a:spcBef>
+                <a:spcPts val="0"/>
+              </a:spcBef>
+              <a:spcAft>
+                <a:spcPts val="0"/>
+              </a:spcAft>
+              <a:buNone/>
+            </a:pPr>
+            <a:endParaRPr/>
+          </a:p>
+        </p:txBody>
+      </p:sp>
+    </p:spTree>
+    <p:extLst>
+      <p:ext uri="{BB962C8B-B14F-4D97-AF65-F5344CB8AC3E}">
+        <p14:creationId xmlns:p14="http://schemas.microsoft.com/office/powerpoint/2010/main" val="557126718"/>
+      </p:ext>
+    </p:extLst>
+  </p:cSld>
+  <p:clrMapOvr>
+    <a:masterClrMapping/>
+  </p:clrMapOvr>
+</p:notes>
+</file>
+
+<file path=ppt/notesSlides/notesSlide15.xml><?xml version="1.0" encoding="utf-8"?>
+<p:notes xmlns:a="http://schemas.openxmlformats.org/drawingml/2006/main" xmlns:r="http://schemas.openxmlformats.org/officeDocument/2006/relationships" xmlns:p="http://schemas.openxmlformats.org/presentationml/2006/main" showMasterSp="0" showMasterPhAnim="0">
+  <p:cSld>
+    <p:spTree>
+      <p:nvGrpSpPr>
+        <p:cNvPr id="1" name="Shape 599">
+          <a:extLst>
+            <a:ext uri="{FF2B5EF4-FFF2-40B4-BE49-F238E27FC236}">
+              <a16:creationId xmlns:a16="http://schemas.microsoft.com/office/drawing/2014/main" id="{3EA30AA2-248B-B0B3-3A2A-485F19BD0218}"/>
+            </a:ext>
+          </a:extLst>
+        </p:cNvPr>
+        <p:cNvGrpSpPr/>
+        <p:nvPr/>
+      </p:nvGrpSpPr>
+      <p:grpSpPr>
+        <a:xfrm>
+          <a:off x="0" y="0"/>
+          <a:ext cx="0" cy="0"/>
+          <a:chOff x="0" y="0"/>
+          <a:chExt cx="0" cy="0"/>
+        </a:xfrm>
+      </p:grpSpPr>
+      <p:sp>
+        <p:nvSpPr>
+          <p:cNvPr id="600" name="Google Shape;600;g200d3bade5e_0_54:notes">
+            <a:extLst>
+              <a:ext uri="{FF2B5EF4-FFF2-40B4-BE49-F238E27FC236}">
+                <a16:creationId xmlns:a16="http://schemas.microsoft.com/office/drawing/2014/main" id="{3EE1E187-7BBF-0DD3-A487-DF8F30766696}"/>
+              </a:ext>
+            </a:extLst>
+          </p:cNvPr>
+          <p:cNvSpPr>
+            <a:spLocks noGrp="1" noRot="1" noChangeAspect="1"/>
+          </p:cNvSpPr>
+          <p:nvPr>
+            <p:ph type="sldImg" idx="2"/>
+          </p:nvPr>
+        </p:nvSpPr>
+        <p:spPr>
+          <a:xfrm>
+            <a:off x="381000" y="685800"/>
+            <a:ext cx="6096000" cy="3429000"/>
+          </a:xfrm>
+          <a:custGeom>
+            <a:avLst/>
+            <a:gdLst/>
+            <a:ahLst/>
+            <a:cxnLst/>
+            <a:rect l="l" t="t" r="r" b="b"/>
+            <a:pathLst>
+              <a:path w="120000" h="120000" extrusionOk="0">
+                <a:moveTo>
+                  <a:pt x="0" y="0"/>
+                </a:moveTo>
+                <a:lnTo>
+                  <a:pt x="120000" y="0"/>
+                </a:lnTo>
+                <a:lnTo>
+                  <a:pt x="120000" y="120000"/>
+                </a:lnTo>
+                <a:lnTo>
+                  <a:pt x="0" y="120000"/>
+                </a:lnTo>
+                <a:close/>
+              </a:path>
+            </a:pathLst>
+          </a:custGeom>
+        </p:spPr>
+      </p:sp>
+      <p:sp>
+        <p:nvSpPr>
+          <p:cNvPr id="601" name="Google Shape;601;g200d3bade5e_0_54:notes">
+            <a:extLst>
+              <a:ext uri="{FF2B5EF4-FFF2-40B4-BE49-F238E27FC236}">
+                <a16:creationId xmlns:a16="http://schemas.microsoft.com/office/drawing/2014/main" id="{0772704C-2490-A50F-1C2F-1CD61AED8FDB}"/>
+              </a:ext>
+            </a:extLst>
+          </p:cNvPr>
+          <p:cNvSpPr txBox="1">
+            <a:spLocks noGrp="1"/>
+          </p:cNvSpPr>
+          <p:nvPr>
+            <p:ph type="body" idx="1"/>
+          </p:nvPr>
+        </p:nvSpPr>
+        <p:spPr>
+          <a:xfrm>
+            <a:off x="685800" y="4343400"/>
+            <a:ext cx="5486400" cy="4114800"/>
+          </a:xfrm>
+          <a:prstGeom prst="rect">
+            <a:avLst/>
+          </a:prstGeom>
+        </p:spPr>
+        <p:txBody>
+          <a:bodyPr spcFirstLastPara="1" wrap="square" lIns="91425" tIns="91425" rIns="91425" bIns="91425" anchor="t" anchorCtr="0">
+            <a:noAutofit/>
+          </a:bodyPr>
+          <a:lstStyle/>
+          <a:p>
+            <a:pPr marL="0" lvl="0" indent="0" algn="l" rtl="0">
+              <a:spcBef>
+                <a:spcPts val="0"/>
+              </a:spcBef>
+              <a:spcAft>
+                <a:spcPts val="0"/>
+              </a:spcAft>
+              <a:buNone/>
+            </a:pPr>
+            <a:endParaRPr/>
+          </a:p>
+        </p:txBody>
+      </p:sp>
+    </p:spTree>
+    <p:extLst>
+      <p:ext uri="{BB962C8B-B14F-4D97-AF65-F5344CB8AC3E}">
+        <p14:creationId xmlns:p14="http://schemas.microsoft.com/office/powerpoint/2010/main" val="2111309535"/>
+      </p:ext>
+    </p:extLst>
+  </p:cSld>
+  <p:clrMapOvr>
+    <a:masterClrMapping/>
+  </p:clrMapOvr>
+</p:notes>
+</file>
+
+<file path=ppt/notesSlides/notesSlide16.xml><?xml version="1.0" encoding="utf-8"?>
+<p:notes xmlns:a="http://schemas.openxmlformats.org/drawingml/2006/main" xmlns:r="http://schemas.openxmlformats.org/officeDocument/2006/relationships" xmlns:p="http://schemas.openxmlformats.org/presentationml/2006/main" showMasterSp="0" showMasterPhAnim="0">
+  <p:cSld>
+    <p:spTree>
+      <p:nvGrpSpPr>
         <p:cNvPr id="1" name="Shape 585"/>
         <p:cNvGrpSpPr/>
         <p:nvPr/>
@@ -1428,7 +1689,7 @@
 </p:notes>
 </file>
 
-<file path=ppt/notesSlides/notesSlide15.xml><?xml version="1.0" encoding="utf-8"?>
+<file path=ppt/notesSlides/notesSlide17.xml><?xml version="1.0" encoding="utf-8"?>
 <p:notes xmlns:a="http://schemas.openxmlformats.org/drawingml/2006/main" xmlns:r="http://schemas.openxmlformats.org/officeDocument/2006/relationships" xmlns:p="http://schemas.openxmlformats.org/presentationml/2006/main" showMasterSp="0" showMasterPhAnim="0">
   <p:cSld>
     <p:spTree>
@@ -23063,6 +23324,4368 @@
   <p:cSld>
     <p:spTree>
       <p:nvGrpSpPr>
+        <p:cNvPr id="1" name="Shape 281">
+          <a:extLst>
+            <a:ext uri="{FF2B5EF4-FFF2-40B4-BE49-F238E27FC236}">
+              <a16:creationId xmlns:a16="http://schemas.microsoft.com/office/drawing/2014/main" id="{A71654B9-7027-DE13-B238-B929CC429490}"/>
+            </a:ext>
+          </a:extLst>
+        </p:cNvPr>
+        <p:cNvGrpSpPr/>
+        <p:nvPr/>
+      </p:nvGrpSpPr>
+      <p:grpSpPr>
+        <a:xfrm>
+          <a:off x="0" y="0"/>
+          <a:ext cx="0" cy="0"/>
+          <a:chOff x="0" y="0"/>
+          <a:chExt cx="0" cy="0"/>
+        </a:xfrm>
+      </p:grpSpPr>
+      <p:pic>
+        <p:nvPicPr>
+          <p:cNvPr id="282" name="Google Shape;282;p37">
+            <a:extLst>
+              <a:ext uri="{FF2B5EF4-FFF2-40B4-BE49-F238E27FC236}">
+                <a16:creationId xmlns:a16="http://schemas.microsoft.com/office/drawing/2014/main" id="{7ABAAD67-D560-BB08-40A0-59758643E3AD}"/>
+              </a:ext>
+            </a:extLst>
+          </p:cNvPr>
+          <p:cNvPicPr preferRelativeResize="0"/>
+          <p:nvPr/>
+        </p:nvPicPr>
+        <p:blipFill>
+          <a:blip r:embed="rId3">
+            <a:alphaModFix/>
+          </a:blip>
+          <a:stretch>
+            <a:fillRect/>
+          </a:stretch>
+        </p:blipFill>
+        <p:spPr>
+          <a:xfrm flipH="1">
+            <a:off x="1920825" y="3759600"/>
+            <a:ext cx="2958919" cy="712350"/>
+          </a:xfrm>
+          <a:prstGeom prst="rect">
+            <a:avLst/>
+          </a:prstGeom>
+          <a:noFill/>
+          <a:ln>
+            <a:noFill/>
+          </a:ln>
+        </p:spPr>
+      </p:pic>
+      <p:pic>
+        <p:nvPicPr>
+          <p:cNvPr id="283" name="Google Shape;283;p37">
+            <a:extLst>
+              <a:ext uri="{FF2B5EF4-FFF2-40B4-BE49-F238E27FC236}">
+                <a16:creationId xmlns:a16="http://schemas.microsoft.com/office/drawing/2014/main" id="{8AE42FFC-32B9-49CF-1DA6-0D1AF61D52CE}"/>
+              </a:ext>
+            </a:extLst>
+          </p:cNvPr>
+          <p:cNvPicPr preferRelativeResize="0"/>
+          <p:nvPr/>
+        </p:nvPicPr>
+        <p:blipFill>
+          <a:blip r:embed="rId4">
+            <a:alphaModFix/>
+          </a:blip>
+          <a:stretch>
+            <a:fillRect/>
+          </a:stretch>
+        </p:blipFill>
+        <p:spPr>
+          <a:xfrm>
+            <a:off x="-190488" y="521554"/>
+            <a:ext cx="3394926" cy="817275"/>
+          </a:xfrm>
+          <a:prstGeom prst="rect">
+            <a:avLst/>
+          </a:prstGeom>
+          <a:noFill/>
+          <a:ln>
+            <a:noFill/>
+          </a:ln>
+        </p:spPr>
+      </p:pic>
+      <p:sp>
+        <p:nvSpPr>
+          <p:cNvPr id="284" name="Google Shape;284;p37">
+            <a:extLst>
+              <a:ext uri="{FF2B5EF4-FFF2-40B4-BE49-F238E27FC236}">
+                <a16:creationId xmlns:a16="http://schemas.microsoft.com/office/drawing/2014/main" id="{48956ED4-4E3F-ECE9-FAD8-A126570B6828}"/>
+              </a:ext>
+            </a:extLst>
+          </p:cNvPr>
+          <p:cNvSpPr txBox="1">
+            <a:spLocks noGrp="1"/>
+          </p:cNvSpPr>
+          <p:nvPr>
+            <p:ph type="title"/>
+          </p:nvPr>
+        </p:nvSpPr>
+        <p:spPr>
+          <a:xfrm>
+            <a:off x="1258263" y="1465156"/>
+            <a:ext cx="5652654" cy="1829207"/>
+          </a:xfrm>
+          <a:prstGeom prst="rect">
+            <a:avLst/>
+          </a:prstGeom>
+        </p:spPr>
+        <p:txBody>
+          <a:bodyPr spcFirstLastPara="1" wrap="square" lIns="91425" tIns="91425" rIns="91425" bIns="91425" anchor="b" anchorCtr="0">
+            <a:noAutofit/>
+          </a:bodyPr>
+          <a:lstStyle/>
+          <a:p>
+            <a:pPr lvl="0" algn="ctr"/>
+            <a:r>
+              <a:rPr lang="fr-FR" dirty="0"/>
+              <a:t>Correction </a:t>
+            </a:r>
+            <a:r>
+              <a:rPr lang="fr-FR" dirty="0" err="1"/>
+              <a:t>validated</a:t>
+            </a:r>
+            <a:r>
+              <a:rPr lang="fr-FR" dirty="0"/>
+              <a:t> </a:t>
+            </a:r>
+            <a:r>
+              <a:rPr lang="fr-FR" dirty="0" err="1"/>
+              <a:t>with</a:t>
+            </a:r>
+            <a:r>
+              <a:rPr lang="fr-FR" dirty="0"/>
+              <a:t> Water </a:t>
+            </a:r>
+            <a:r>
+              <a:rPr lang="fr-FR" dirty="0" err="1"/>
+              <a:t>Supply</a:t>
+            </a:r>
+            <a:endParaRPr dirty="0"/>
+          </a:p>
+        </p:txBody>
+      </p:sp>
+      <p:pic>
+        <p:nvPicPr>
+          <p:cNvPr id="286" name="Google Shape;286;p37">
+            <a:extLst>
+              <a:ext uri="{FF2B5EF4-FFF2-40B4-BE49-F238E27FC236}">
+                <a16:creationId xmlns:a16="http://schemas.microsoft.com/office/drawing/2014/main" id="{AB2D5E58-4305-A007-2A67-0EFAE3B6639A}"/>
+              </a:ext>
+            </a:extLst>
+          </p:cNvPr>
+          <p:cNvPicPr preferRelativeResize="0"/>
+          <p:nvPr/>
+        </p:nvPicPr>
+        <p:blipFill>
+          <a:blip r:embed="rId5">
+            <a:alphaModFix/>
+          </a:blip>
+          <a:stretch>
+            <a:fillRect/>
+          </a:stretch>
+        </p:blipFill>
+        <p:spPr>
+          <a:xfrm rot="141079" flipH="1">
+            <a:off x="155138" y="3182037"/>
+            <a:ext cx="2156824" cy="1136319"/>
+          </a:xfrm>
+          <a:prstGeom prst="rect">
+            <a:avLst/>
+          </a:prstGeom>
+          <a:noFill/>
+          <a:ln>
+            <a:noFill/>
+          </a:ln>
+        </p:spPr>
+      </p:pic>
+      <p:pic>
+        <p:nvPicPr>
+          <p:cNvPr id="287" name="Google Shape;287;p37">
+            <a:extLst>
+              <a:ext uri="{FF2B5EF4-FFF2-40B4-BE49-F238E27FC236}">
+                <a16:creationId xmlns:a16="http://schemas.microsoft.com/office/drawing/2014/main" id="{6D8483C7-9935-453A-8BEE-66C022B0219A}"/>
+              </a:ext>
+            </a:extLst>
+          </p:cNvPr>
+          <p:cNvPicPr preferRelativeResize="0"/>
+          <p:nvPr/>
+        </p:nvPicPr>
+        <p:blipFill>
+          <a:blip r:embed="rId6">
+            <a:alphaModFix/>
+          </a:blip>
+          <a:stretch>
+            <a:fillRect/>
+          </a:stretch>
+        </p:blipFill>
+        <p:spPr>
+          <a:xfrm>
+            <a:off x="0" y="3993431"/>
+            <a:ext cx="9144000" cy="1042988"/>
+          </a:xfrm>
+          <a:prstGeom prst="rect">
+            <a:avLst/>
+          </a:prstGeom>
+          <a:noFill/>
+          <a:ln>
+            <a:noFill/>
+          </a:ln>
+        </p:spPr>
+      </p:pic>
+      <p:sp>
+        <p:nvSpPr>
+          <p:cNvPr id="288" name="Google Shape;288;p37">
+            <a:extLst>
+              <a:ext uri="{FF2B5EF4-FFF2-40B4-BE49-F238E27FC236}">
+                <a16:creationId xmlns:a16="http://schemas.microsoft.com/office/drawing/2014/main" id="{FF2D7110-C4FC-BCEE-2E7C-509C134DA315}"/>
+              </a:ext>
+            </a:extLst>
+          </p:cNvPr>
+          <p:cNvSpPr/>
+          <p:nvPr/>
+        </p:nvSpPr>
+        <p:spPr>
+          <a:xfrm>
+            <a:off x="7745073" y="816009"/>
+            <a:ext cx="519178" cy="422401"/>
+          </a:xfrm>
+          <a:custGeom>
+            <a:avLst/>
+            <a:gdLst/>
+            <a:ahLst/>
+            <a:cxnLst/>
+            <a:rect l="l" t="t" r="r" b="b"/>
+            <a:pathLst>
+              <a:path w="8385" h="6822" extrusionOk="0">
+                <a:moveTo>
+                  <a:pt x="6100" y="5412"/>
+                </a:moveTo>
+                <a:cubicBezTo>
+                  <a:pt x="8385" y="2725"/>
+                  <a:pt x="1940" y="0"/>
+                  <a:pt x="524" y="2496"/>
+                </a:cubicBezTo>
+                <a:cubicBezTo>
+                  <a:pt x="1" y="3423"/>
+                  <a:pt x="512" y="5528"/>
+                  <a:pt x="1950" y="6257"/>
+                </a:cubicBezTo>
+                <a:cubicBezTo>
+                  <a:pt x="3061" y="6821"/>
+                  <a:pt x="4921" y="6297"/>
+                  <a:pt x="6100" y="5412"/>
+                </a:cubicBezTo>
+                <a:close/>
+              </a:path>
+            </a:pathLst>
+          </a:custGeom>
+          <a:solidFill>
+            <a:schemeClr val="dk2"/>
+          </a:solidFill>
+          <a:ln>
+            <a:noFill/>
+          </a:ln>
+        </p:spPr>
+        <p:txBody>
+          <a:bodyPr spcFirstLastPara="1" wrap="square" lIns="91425" tIns="91425" rIns="91425" bIns="91425" anchor="ctr" anchorCtr="0">
+            <a:noAutofit/>
+          </a:bodyPr>
+          <a:lstStyle/>
+          <a:p>
+            <a:pPr marL="0" lvl="0" indent="0" algn="l" rtl="0">
+              <a:spcBef>
+                <a:spcPts val="0"/>
+              </a:spcBef>
+              <a:spcAft>
+                <a:spcPts val="0"/>
+              </a:spcAft>
+              <a:buNone/>
+            </a:pPr>
+            <a:endParaRPr/>
+          </a:p>
+        </p:txBody>
+      </p:sp>
+      <p:sp>
+        <p:nvSpPr>
+          <p:cNvPr id="289" name="Google Shape;289;p37">
+            <a:extLst>
+              <a:ext uri="{FF2B5EF4-FFF2-40B4-BE49-F238E27FC236}">
+                <a16:creationId xmlns:a16="http://schemas.microsoft.com/office/drawing/2014/main" id="{D5C1918D-39E2-F497-0FA9-D696AAECF117}"/>
+              </a:ext>
+            </a:extLst>
+          </p:cNvPr>
+          <p:cNvSpPr/>
+          <p:nvPr/>
+        </p:nvSpPr>
+        <p:spPr>
+          <a:xfrm rot="2026369">
+            <a:off x="7554510" y="3250056"/>
+            <a:ext cx="1067304" cy="2476820"/>
+          </a:xfrm>
+          <a:custGeom>
+            <a:avLst/>
+            <a:gdLst/>
+            <a:ahLst/>
+            <a:cxnLst/>
+            <a:rect l="l" t="t" r="r" b="b"/>
+            <a:pathLst>
+              <a:path w="4267" h="9902" extrusionOk="0">
+                <a:moveTo>
+                  <a:pt x="4244" y="9799"/>
+                </a:moveTo>
+                <a:cubicBezTo>
+                  <a:pt x="4017" y="9623"/>
+                  <a:pt x="3808" y="9439"/>
+                  <a:pt x="3614" y="9246"/>
+                </a:cubicBezTo>
+                <a:cubicBezTo>
+                  <a:pt x="3733" y="9122"/>
+                  <a:pt x="4203" y="8547"/>
+                  <a:pt x="3577" y="7829"/>
+                </a:cubicBezTo>
+                <a:cubicBezTo>
+                  <a:pt x="3569" y="7552"/>
+                  <a:pt x="3499" y="7280"/>
+                  <a:pt x="3383" y="7047"/>
+                </a:cubicBezTo>
+                <a:cubicBezTo>
+                  <a:pt x="3377" y="7041"/>
+                  <a:pt x="3362" y="7047"/>
+                  <a:pt x="3367" y="7057"/>
+                </a:cubicBezTo>
+                <a:cubicBezTo>
+                  <a:pt x="3459" y="7262"/>
+                  <a:pt x="3512" y="7475"/>
+                  <a:pt x="3528" y="7706"/>
+                </a:cubicBezTo>
+                <a:cubicBezTo>
+                  <a:pt x="3530" y="7728"/>
+                  <a:pt x="3530" y="7751"/>
+                  <a:pt x="3530" y="7773"/>
+                </a:cubicBezTo>
+                <a:cubicBezTo>
+                  <a:pt x="3506" y="7749"/>
+                  <a:pt x="3479" y="7720"/>
+                  <a:pt x="3450" y="7696"/>
+                </a:cubicBezTo>
+                <a:cubicBezTo>
+                  <a:pt x="3448" y="7692"/>
+                  <a:pt x="3444" y="7690"/>
+                  <a:pt x="3440" y="7687"/>
+                </a:cubicBezTo>
+                <a:cubicBezTo>
+                  <a:pt x="3409" y="7389"/>
+                  <a:pt x="3307" y="7098"/>
+                  <a:pt x="3150" y="6867"/>
+                </a:cubicBezTo>
+                <a:cubicBezTo>
+                  <a:pt x="3141" y="6857"/>
+                  <a:pt x="3127" y="6867"/>
+                  <a:pt x="3131" y="6877"/>
+                </a:cubicBezTo>
+                <a:cubicBezTo>
+                  <a:pt x="3244" y="7065"/>
+                  <a:pt x="3324" y="7272"/>
+                  <a:pt x="3367" y="7495"/>
+                </a:cubicBezTo>
+                <a:cubicBezTo>
+                  <a:pt x="3379" y="7559"/>
+                  <a:pt x="3385" y="7626"/>
+                  <a:pt x="3389" y="7692"/>
+                </a:cubicBezTo>
+                <a:cubicBezTo>
+                  <a:pt x="3387" y="7696"/>
+                  <a:pt x="3385" y="7698"/>
+                  <a:pt x="3383" y="7698"/>
+                </a:cubicBezTo>
+                <a:cubicBezTo>
+                  <a:pt x="3377" y="7700"/>
+                  <a:pt x="3375" y="7710"/>
+                  <a:pt x="3373" y="7714"/>
+                </a:cubicBezTo>
+                <a:cubicBezTo>
+                  <a:pt x="3364" y="7737"/>
+                  <a:pt x="3354" y="7759"/>
+                  <a:pt x="3346" y="7780"/>
+                </a:cubicBezTo>
+                <a:cubicBezTo>
+                  <a:pt x="3338" y="7559"/>
+                  <a:pt x="3254" y="7299"/>
+                  <a:pt x="3027" y="6998"/>
+                </a:cubicBezTo>
+                <a:lnTo>
+                  <a:pt x="3027" y="6998"/>
+                </a:lnTo>
+                <a:cubicBezTo>
+                  <a:pt x="3051" y="6738"/>
+                  <a:pt x="3029" y="6476"/>
+                  <a:pt x="2955" y="6241"/>
+                </a:cubicBezTo>
+                <a:cubicBezTo>
+                  <a:pt x="2953" y="6231"/>
+                  <a:pt x="2935" y="6237"/>
+                  <a:pt x="2937" y="6247"/>
+                </a:cubicBezTo>
+                <a:cubicBezTo>
+                  <a:pt x="2994" y="6466"/>
+                  <a:pt x="3011" y="6687"/>
+                  <a:pt x="2990" y="6920"/>
+                </a:cubicBezTo>
+                <a:lnTo>
+                  <a:pt x="2982" y="6982"/>
+                </a:lnTo>
+                <a:cubicBezTo>
+                  <a:pt x="2976" y="6982"/>
+                  <a:pt x="2966" y="6986"/>
+                  <a:pt x="2959" y="6994"/>
+                </a:cubicBezTo>
+                <a:cubicBezTo>
+                  <a:pt x="2951" y="6998"/>
+                  <a:pt x="2947" y="7006"/>
+                  <a:pt x="2945" y="7012"/>
+                </a:cubicBezTo>
+                <a:cubicBezTo>
+                  <a:pt x="2943" y="7014"/>
+                  <a:pt x="2943" y="7016"/>
+                  <a:pt x="2939" y="7023"/>
+                </a:cubicBezTo>
+                <a:cubicBezTo>
+                  <a:pt x="2996" y="6720"/>
+                  <a:pt x="2943" y="6347"/>
+                  <a:pt x="2620" y="5942"/>
+                </a:cubicBezTo>
+                <a:cubicBezTo>
+                  <a:pt x="2599" y="5713"/>
+                  <a:pt x="2538" y="5490"/>
+                  <a:pt x="2444" y="5296"/>
+                </a:cubicBezTo>
+                <a:cubicBezTo>
+                  <a:pt x="2436" y="5286"/>
+                  <a:pt x="2417" y="5292"/>
+                  <a:pt x="2423" y="5304"/>
+                </a:cubicBezTo>
+                <a:cubicBezTo>
+                  <a:pt x="2505" y="5498"/>
+                  <a:pt x="2556" y="5701"/>
+                  <a:pt x="2573" y="5916"/>
+                </a:cubicBezTo>
+                <a:cubicBezTo>
+                  <a:pt x="2560" y="5916"/>
+                  <a:pt x="2548" y="5922"/>
+                  <a:pt x="2536" y="5932"/>
+                </a:cubicBezTo>
+                <a:cubicBezTo>
+                  <a:pt x="2528" y="5940"/>
+                  <a:pt x="2522" y="5948"/>
+                  <a:pt x="2519" y="5957"/>
+                </a:cubicBezTo>
+                <a:cubicBezTo>
+                  <a:pt x="2517" y="5961"/>
+                  <a:pt x="2515" y="5967"/>
+                  <a:pt x="2511" y="5969"/>
+                </a:cubicBezTo>
+                <a:cubicBezTo>
+                  <a:pt x="2497" y="5717"/>
+                  <a:pt x="2436" y="5472"/>
+                  <a:pt x="2333" y="5263"/>
+                </a:cubicBezTo>
+                <a:cubicBezTo>
+                  <a:pt x="2325" y="5255"/>
+                  <a:pt x="2307" y="5261"/>
+                  <a:pt x="2313" y="5271"/>
+                </a:cubicBezTo>
+                <a:cubicBezTo>
+                  <a:pt x="2399" y="5478"/>
+                  <a:pt x="2454" y="5691"/>
+                  <a:pt x="2466" y="5920"/>
+                </a:cubicBezTo>
+                <a:cubicBezTo>
+                  <a:pt x="2468" y="5969"/>
+                  <a:pt x="2468" y="6018"/>
+                  <a:pt x="2466" y="6065"/>
+                </a:cubicBezTo>
+                <a:cubicBezTo>
+                  <a:pt x="2458" y="6083"/>
+                  <a:pt x="2448" y="6102"/>
+                  <a:pt x="2440" y="6120"/>
+                </a:cubicBezTo>
+                <a:cubicBezTo>
+                  <a:pt x="2405" y="5950"/>
+                  <a:pt x="2333" y="5766"/>
+                  <a:pt x="2209" y="5564"/>
+                </a:cubicBezTo>
+                <a:cubicBezTo>
+                  <a:pt x="2202" y="5554"/>
+                  <a:pt x="2192" y="5547"/>
+                  <a:pt x="2184" y="5543"/>
+                </a:cubicBezTo>
+                <a:cubicBezTo>
+                  <a:pt x="2239" y="5296"/>
+                  <a:pt x="2211" y="5030"/>
+                  <a:pt x="2090" y="4823"/>
+                </a:cubicBezTo>
+                <a:cubicBezTo>
+                  <a:pt x="2080" y="4813"/>
+                  <a:pt x="2065" y="4825"/>
+                  <a:pt x="2073" y="4835"/>
+                </a:cubicBezTo>
+                <a:cubicBezTo>
+                  <a:pt x="2168" y="5015"/>
+                  <a:pt x="2168" y="5200"/>
+                  <a:pt x="2153" y="5390"/>
+                </a:cubicBezTo>
+                <a:cubicBezTo>
+                  <a:pt x="2137" y="5234"/>
+                  <a:pt x="2088" y="5063"/>
+                  <a:pt x="2000" y="4874"/>
+                </a:cubicBezTo>
+                <a:cubicBezTo>
+                  <a:pt x="2100" y="4608"/>
+                  <a:pt x="2098" y="4295"/>
+                  <a:pt x="2133" y="4035"/>
+                </a:cubicBezTo>
+                <a:cubicBezTo>
+                  <a:pt x="2133" y="4025"/>
+                  <a:pt x="2121" y="4025"/>
+                  <a:pt x="2118" y="4033"/>
+                </a:cubicBezTo>
+                <a:cubicBezTo>
+                  <a:pt x="2082" y="4191"/>
+                  <a:pt x="2051" y="4351"/>
+                  <a:pt x="2026" y="4510"/>
+                </a:cubicBezTo>
+                <a:cubicBezTo>
+                  <a:pt x="2010" y="4608"/>
+                  <a:pt x="1986" y="4698"/>
+                  <a:pt x="1957" y="4784"/>
+                </a:cubicBezTo>
+                <a:cubicBezTo>
+                  <a:pt x="1953" y="4776"/>
+                  <a:pt x="1945" y="4770"/>
+                  <a:pt x="1936" y="4764"/>
+                </a:cubicBezTo>
+                <a:cubicBezTo>
+                  <a:pt x="2028" y="4459"/>
+                  <a:pt x="1973" y="4107"/>
+                  <a:pt x="1973" y="3804"/>
+                </a:cubicBezTo>
+                <a:cubicBezTo>
+                  <a:pt x="1971" y="3794"/>
+                  <a:pt x="1953" y="3794"/>
+                  <a:pt x="1953" y="3804"/>
+                </a:cubicBezTo>
+                <a:cubicBezTo>
+                  <a:pt x="1928" y="3956"/>
+                  <a:pt x="1936" y="4107"/>
+                  <a:pt x="1936" y="4256"/>
+                </a:cubicBezTo>
+                <a:lnTo>
+                  <a:pt x="1936" y="4291"/>
+                </a:lnTo>
+                <a:cubicBezTo>
+                  <a:pt x="1920" y="4164"/>
+                  <a:pt x="1883" y="4027"/>
+                  <a:pt x="1826" y="3878"/>
+                </a:cubicBezTo>
+                <a:cubicBezTo>
+                  <a:pt x="2078" y="3598"/>
+                  <a:pt x="2141" y="3127"/>
+                  <a:pt x="2188" y="2790"/>
+                </a:cubicBezTo>
+                <a:cubicBezTo>
+                  <a:pt x="2188" y="2777"/>
+                  <a:pt x="2168" y="2771"/>
+                  <a:pt x="2164" y="2785"/>
+                </a:cubicBezTo>
+                <a:cubicBezTo>
+                  <a:pt x="2086" y="3168"/>
+                  <a:pt x="1986" y="3504"/>
+                  <a:pt x="1781" y="3833"/>
+                </a:cubicBezTo>
+                <a:lnTo>
+                  <a:pt x="1779" y="3833"/>
+                </a:lnTo>
+                <a:cubicBezTo>
+                  <a:pt x="1801" y="3772"/>
+                  <a:pt x="1822" y="3702"/>
+                  <a:pt x="1836" y="3628"/>
+                </a:cubicBezTo>
+                <a:cubicBezTo>
+                  <a:pt x="1994" y="3371"/>
+                  <a:pt x="2000" y="3000"/>
+                  <a:pt x="2008" y="2730"/>
+                </a:cubicBezTo>
+                <a:cubicBezTo>
+                  <a:pt x="2010" y="2724"/>
+                  <a:pt x="1994" y="2724"/>
+                  <a:pt x="1990" y="2734"/>
+                </a:cubicBezTo>
+                <a:cubicBezTo>
+                  <a:pt x="1967" y="2974"/>
+                  <a:pt x="1934" y="3195"/>
+                  <a:pt x="1863" y="3409"/>
+                </a:cubicBezTo>
+                <a:cubicBezTo>
+                  <a:pt x="1867" y="3242"/>
+                  <a:pt x="1846" y="3053"/>
+                  <a:pt x="1785" y="2837"/>
+                </a:cubicBezTo>
+                <a:cubicBezTo>
+                  <a:pt x="1783" y="2826"/>
+                  <a:pt x="1779" y="2818"/>
+                  <a:pt x="1771" y="2810"/>
+                </a:cubicBezTo>
+                <a:cubicBezTo>
+                  <a:pt x="1789" y="2769"/>
+                  <a:pt x="1803" y="2726"/>
+                  <a:pt x="1820" y="2679"/>
+                </a:cubicBezTo>
+                <a:cubicBezTo>
+                  <a:pt x="1996" y="2407"/>
+                  <a:pt x="2037" y="2049"/>
+                  <a:pt x="2022" y="1744"/>
+                </a:cubicBezTo>
+                <a:cubicBezTo>
+                  <a:pt x="2022" y="1732"/>
+                  <a:pt x="2004" y="1734"/>
+                  <a:pt x="2004" y="1746"/>
+                </a:cubicBezTo>
+                <a:cubicBezTo>
+                  <a:pt x="2002" y="1936"/>
+                  <a:pt x="1981" y="2125"/>
+                  <a:pt x="1932" y="2311"/>
+                </a:cubicBezTo>
+                <a:cubicBezTo>
+                  <a:pt x="1914" y="2376"/>
+                  <a:pt x="1891" y="2434"/>
+                  <a:pt x="1865" y="2491"/>
+                </a:cubicBezTo>
+                <a:cubicBezTo>
+                  <a:pt x="1902" y="2284"/>
+                  <a:pt x="1895" y="2045"/>
+                  <a:pt x="1822" y="1773"/>
+                </a:cubicBezTo>
+                <a:cubicBezTo>
+                  <a:pt x="1981" y="1541"/>
+                  <a:pt x="2100" y="1267"/>
+                  <a:pt x="2151" y="1010"/>
+                </a:cubicBezTo>
+                <a:cubicBezTo>
+                  <a:pt x="2155" y="999"/>
+                  <a:pt x="2137" y="997"/>
+                  <a:pt x="2135" y="1008"/>
+                </a:cubicBezTo>
+                <a:cubicBezTo>
+                  <a:pt x="2055" y="1265"/>
+                  <a:pt x="1916" y="1482"/>
+                  <a:pt x="1783" y="1707"/>
+                </a:cubicBezTo>
+                <a:lnTo>
+                  <a:pt x="1781" y="1707"/>
+                </a:lnTo>
+                <a:cubicBezTo>
+                  <a:pt x="1875" y="1480"/>
+                  <a:pt x="1926" y="1222"/>
+                  <a:pt x="1920" y="991"/>
+                </a:cubicBezTo>
+                <a:cubicBezTo>
+                  <a:pt x="1916" y="985"/>
+                  <a:pt x="1902" y="985"/>
+                  <a:pt x="1902" y="995"/>
+                </a:cubicBezTo>
+                <a:cubicBezTo>
+                  <a:pt x="1883" y="1253"/>
+                  <a:pt x="1793" y="1482"/>
+                  <a:pt x="1717" y="1726"/>
+                </a:cubicBezTo>
+                <a:cubicBezTo>
+                  <a:pt x="1668" y="1767"/>
+                  <a:pt x="1623" y="1805"/>
+                  <a:pt x="1578" y="1842"/>
+                </a:cubicBezTo>
+                <a:cubicBezTo>
+                  <a:pt x="1638" y="1609"/>
+                  <a:pt x="1634" y="1306"/>
+                  <a:pt x="1476" y="934"/>
+                </a:cubicBezTo>
+                <a:cubicBezTo>
+                  <a:pt x="1554" y="654"/>
+                  <a:pt x="1615" y="381"/>
+                  <a:pt x="1760" y="109"/>
+                </a:cubicBezTo>
+                <a:cubicBezTo>
+                  <a:pt x="1767" y="97"/>
+                  <a:pt x="1750" y="89"/>
+                  <a:pt x="1742" y="99"/>
+                </a:cubicBezTo>
+                <a:cubicBezTo>
+                  <a:pt x="1599" y="308"/>
+                  <a:pt x="1486" y="570"/>
+                  <a:pt x="1425" y="827"/>
+                </a:cubicBezTo>
+                <a:cubicBezTo>
+                  <a:pt x="1411" y="815"/>
+                  <a:pt x="1388" y="813"/>
+                  <a:pt x="1364" y="825"/>
+                </a:cubicBezTo>
+                <a:cubicBezTo>
+                  <a:pt x="1362" y="825"/>
+                  <a:pt x="1362" y="827"/>
+                  <a:pt x="1359" y="827"/>
+                </a:cubicBezTo>
+                <a:cubicBezTo>
+                  <a:pt x="1433" y="555"/>
+                  <a:pt x="1494" y="285"/>
+                  <a:pt x="1638" y="23"/>
+                </a:cubicBezTo>
+                <a:cubicBezTo>
+                  <a:pt x="1644" y="13"/>
+                  <a:pt x="1625" y="1"/>
+                  <a:pt x="1619" y="15"/>
+                </a:cubicBezTo>
+                <a:cubicBezTo>
+                  <a:pt x="1441" y="273"/>
+                  <a:pt x="1310" y="611"/>
+                  <a:pt x="1267" y="928"/>
+                </a:cubicBezTo>
+                <a:cubicBezTo>
+                  <a:pt x="1065" y="1161"/>
+                  <a:pt x="924" y="1370"/>
+                  <a:pt x="856" y="1572"/>
+                </a:cubicBezTo>
+                <a:cubicBezTo>
+                  <a:pt x="805" y="1509"/>
+                  <a:pt x="748" y="1443"/>
+                  <a:pt x="688" y="1378"/>
+                </a:cubicBezTo>
+                <a:lnTo>
+                  <a:pt x="688" y="1378"/>
+                </a:lnTo>
+                <a:cubicBezTo>
+                  <a:pt x="678" y="1145"/>
+                  <a:pt x="686" y="915"/>
+                  <a:pt x="789" y="682"/>
+                </a:cubicBezTo>
+                <a:cubicBezTo>
+                  <a:pt x="797" y="672"/>
+                  <a:pt x="780" y="664"/>
+                  <a:pt x="774" y="674"/>
+                </a:cubicBezTo>
+                <a:cubicBezTo>
+                  <a:pt x="672" y="866"/>
+                  <a:pt x="611" y="1126"/>
+                  <a:pt x="611" y="1372"/>
+                </a:cubicBezTo>
+                <a:cubicBezTo>
+                  <a:pt x="605" y="1378"/>
+                  <a:pt x="600" y="1386"/>
+                  <a:pt x="596" y="1394"/>
+                </a:cubicBezTo>
+                <a:lnTo>
+                  <a:pt x="582" y="1431"/>
+                </a:lnTo>
+                <a:cubicBezTo>
+                  <a:pt x="543" y="1214"/>
+                  <a:pt x="541" y="997"/>
+                  <a:pt x="643" y="768"/>
+                </a:cubicBezTo>
+                <a:cubicBezTo>
+                  <a:pt x="645" y="764"/>
+                  <a:pt x="635" y="758"/>
+                  <a:pt x="631" y="766"/>
+                </a:cubicBezTo>
+                <a:cubicBezTo>
+                  <a:pt x="504" y="995"/>
+                  <a:pt x="484" y="1286"/>
+                  <a:pt x="539" y="1544"/>
+                </a:cubicBezTo>
+                <a:cubicBezTo>
+                  <a:pt x="355" y="2065"/>
+                  <a:pt x="390" y="2452"/>
+                  <a:pt x="508" y="2728"/>
+                </a:cubicBezTo>
+                <a:cubicBezTo>
+                  <a:pt x="492" y="2716"/>
+                  <a:pt x="474" y="2706"/>
+                  <a:pt x="457" y="2693"/>
+                </a:cubicBezTo>
+                <a:cubicBezTo>
+                  <a:pt x="451" y="2687"/>
+                  <a:pt x="443" y="2685"/>
+                  <a:pt x="437" y="2683"/>
+                </a:cubicBezTo>
+                <a:cubicBezTo>
+                  <a:pt x="422" y="2677"/>
+                  <a:pt x="408" y="2679"/>
+                  <a:pt x="398" y="2685"/>
+                </a:cubicBezTo>
+                <a:cubicBezTo>
+                  <a:pt x="328" y="2474"/>
+                  <a:pt x="279" y="2260"/>
+                  <a:pt x="267" y="2024"/>
+                </a:cubicBezTo>
+                <a:cubicBezTo>
+                  <a:pt x="265" y="2016"/>
+                  <a:pt x="253" y="2016"/>
+                  <a:pt x="253" y="2024"/>
+                </a:cubicBezTo>
+                <a:cubicBezTo>
+                  <a:pt x="244" y="2247"/>
+                  <a:pt x="277" y="2526"/>
+                  <a:pt x="357" y="2777"/>
+                </a:cubicBezTo>
+                <a:cubicBezTo>
+                  <a:pt x="246" y="3352"/>
+                  <a:pt x="345" y="3741"/>
+                  <a:pt x="504" y="3999"/>
+                </a:cubicBezTo>
+                <a:lnTo>
+                  <a:pt x="351" y="3923"/>
+                </a:lnTo>
+                <a:cubicBezTo>
+                  <a:pt x="347" y="3921"/>
+                  <a:pt x="339" y="3921"/>
+                  <a:pt x="330" y="3917"/>
+                </a:cubicBezTo>
+                <a:lnTo>
+                  <a:pt x="326" y="3917"/>
+                </a:lnTo>
+                <a:cubicBezTo>
+                  <a:pt x="144" y="3686"/>
+                  <a:pt x="30" y="3393"/>
+                  <a:pt x="38" y="3084"/>
+                </a:cubicBezTo>
+                <a:cubicBezTo>
+                  <a:pt x="38" y="3068"/>
+                  <a:pt x="17" y="3068"/>
+                  <a:pt x="17" y="3082"/>
+                </a:cubicBezTo>
+                <a:cubicBezTo>
+                  <a:pt x="1" y="3289"/>
+                  <a:pt x="58" y="3487"/>
+                  <a:pt x="132" y="3671"/>
+                </a:cubicBezTo>
+                <a:cubicBezTo>
+                  <a:pt x="165" y="3757"/>
+                  <a:pt x="212" y="3860"/>
+                  <a:pt x="269" y="3945"/>
+                </a:cubicBezTo>
+                <a:cubicBezTo>
+                  <a:pt x="267" y="3952"/>
+                  <a:pt x="265" y="3958"/>
+                  <a:pt x="265" y="3964"/>
+                </a:cubicBezTo>
+                <a:cubicBezTo>
+                  <a:pt x="206" y="4436"/>
+                  <a:pt x="316" y="4745"/>
+                  <a:pt x="482" y="4952"/>
+                </a:cubicBezTo>
+                <a:cubicBezTo>
+                  <a:pt x="478" y="4950"/>
+                  <a:pt x="469" y="4950"/>
+                  <a:pt x="463" y="4950"/>
+                </a:cubicBezTo>
+                <a:cubicBezTo>
+                  <a:pt x="449" y="4950"/>
+                  <a:pt x="437" y="4958"/>
+                  <a:pt x="429" y="4968"/>
+                </a:cubicBezTo>
+                <a:cubicBezTo>
+                  <a:pt x="396" y="4927"/>
+                  <a:pt x="361" y="4885"/>
+                  <a:pt x="330" y="4835"/>
+                </a:cubicBezTo>
+                <a:cubicBezTo>
+                  <a:pt x="244" y="4686"/>
+                  <a:pt x="171" y="4529"/>
+                  <a:pt x="89" y="4375"/>
+                </a:cubicBezTo>
+                <a:cubicBezTo>
+                  <a:pt x="85" y="4365"/>
+                  <a:pt x="73" y="4375"/>
+                  <a:pt x="75" y="4383"/>
+                </a:cubicBezTo>
+                <a:cubicBezTo>
+                  <a:pt x="173" y="4588"/>
+                  <a:pt x="259" y="4854"/>
+                  <a:pt x="408" y="5048"/>
+                </a:cubicBezTo>
+                <a:cubicBezTo>
+                  <a:pt x="422" y="5588"/>
+                  <a:pt x="596" y="5887"/>
+                  <a:pt x="805" y="6051"/>
+                </a:cubicBezTo>
+                <a:cubicBezTo>
+                  <a:pt x="766" y="6045"/>
+                  <a:pt x="725" y="6043"/>
+                  <a:pt x="686" y="6040"/>
+                </a:cubicBezTo>
+                <a:cubicBezTo>
+                  <a:pt x="551" y="5899"/>
+                  <a:pt x="433" y="5736"/>
+                  <a:pt x="330" y="5570"/>
+                </a:cubicBezTo>
+                <a:cubicBezTo>
+                  <a:pt x="324" y="5560"/>
+                  <a:pt x="308" y="5570"/>
+                  <a:pt x="316" y="5580"/>
+                </a:cubicBezTo>
+                <a:cubicBezTo>
+                  <a:pt x="388" y="5709"/>
+                  <a:pt x="482" y="5883"/>
+                  <a:pt x="602" y="6036"/>
+                </a:cubicBezTo>
+                <a:lnTo>
+                  <a:pt x="600" y="6036"/>
+                </a:lnTo>
+                <a:cubicBezTo>
+                  <a:pt x="600" y="6036"/>
+                  <a:pt x="596" y="6036"/>
+                  <a:pt x="596" y="6040"/>
+                </a:cubicBezTo>
+                <a:cubicBezTo>
+                  <a:pt x="576" y="6024"/>
+                  <a:pt x="560" y="6006"/>
+                  <a:pt x="539" y="5985"/>
+                </a:cubicBezTo>
+                <a:cubicBezTo>
+                  <a:pt x="392" y="5840"/>
+                  <a:pt x="269" y="5666"/>
+                  <a:pt x="161" y="5492"/>
+                </a:cubicBezTo>
+                <a:cubicBezTo>
+                  <a:pt x="152" y="5482"/>
+                  <a:pt x="140" y="5494"/>
+                  <a:pt x="144" y="5502"/>
+                </a:cubicBezTo>
+                <a:cubicBezTo>
+                  <a:pt x="238" y="5676"/>
+                  <a:pt x="377" y="5924"/>
+                  <a:pt x="555" y="6100"/>
+                </a:cubicBezTo>
+                <a:lnTo>
+                  <a:pt x="555" y="6110"/>
+                </a:lnTo>
+                <a:cubicBezTo>
+                  <a:pt x="686" y="6701"/>
+                  <a:pt x="958" y="6961"/>
+                  <a:pt x="1226" y="7059"/>
+                </a:cubicBezTo>
+                <a:cubicBezTo>
+                  <a:pt x="1114" y="7063"/>
+                  <a:pt x="999" y="7072"/>
+                  <a:pt x="877" y="7084"/>
+                </a:cubicBezTo>
+                <a:cubicBezTo>
+                  <a:pt x="870" y="7084"/>
+                  <a:pt x="862" y="7086"/>
+                  <a:pt x="858" y="7088"/>
+                </a:cubicBezTo>
+                <a:cubicBezTo>
+                  <a:pt x="697" y="6963"/>
+                  <a:pt x="551" y="6797"/>
+                  <a:pt x="451" y="6605"/>
+                </a:cubicBezTo>
+                <a:cubicBezTo>
+                  <a:pt x="447" y="6597"/>
+                  <a:pt x="431" y="6607"/>
+                  <a:pt x="437" y="6617"/>
+                </a:cubicBezTo>
+                <a:cubicBezTo>
+                  <a:pt x="523" y="6818"/>
+                  <a:pt x="652" y="6973"/>
+                  <a:pt x="805" y="7111"/>
+                </a:cubicBezTo>
+                <a:cubicBezTo>
+                  <a:pt x="811" y="7117"/>
+                  <a:pt x="817" y="7125"/>
+                  <a:pt x="825" y="7129"/>
+                </a:cubicBezTo>
+                <a:cubicBezTo>
+                  <a:pt x="821" y="7139"/>
+                  <a:pt x="825" y="7151"/>
+                  <a:pt x="830" y="7162"/>
+                </a:cubicBezTo>
+                <a:cubicBezTo>
+                  <a:pt x="1374" y="8181"/>
+                  <a:pt x="2131" y="7976"/>
+                  <a:pt x="2397" y="7861"/>
+                </a:cubicBezTo>
+                <a:cubicBezTo>
+                  <a:pt x="2436" y="7927"/>
+                  <a:pt x="2477" y="7994"/>
+                  <a:pt x="2517" y="8060"/>
+                </a:cubicBezTo>
+                <a:cubicBezTo>
+                  <a:pt x="2474" y="8039"/>
+                  <a:pt x="2425" y="8023"/>
+                  <a:pt x="2376" y="8007"/>
+                </a:cubicBezTo>
+                <a:cubicBezTo>
+                  <a:pt x="2141" y="7941"/>
+                  <a:pt x="1859" y="7962"/>
+                  <a:pt x="1527" y="8025"/>
+                </a:cubicBezTo>
+                <a:cubicBezTo>
+                  <a:pt x="1523" y="8025"/>
+                  <a:pt x="1517" y="8027"/>
+                  <a:pt x="1515" y="8027"/>
+                </a:cubicBezTo>
+                <a:cubicBezTo>
+                  <a:pt x="1339" y="7915"/>
+                  <a:pt x="1173" y="7769"/>
+                  <a:pt x="1051" y="7604"/>
+                </a:cubicBezTo>
+                <a:cubicBezTo>
+                  <a:pt x="1042" y="7593"/>
+                  <a:pt x="1026" y="7599"/>
+                  <a:pt x="1032" y="7610"/>
+                </a:cubicBezTo>
+                <a:cubicBezTo>
+                  <a:pt x="1153" y="7794"/>
+                  <a:pt x="1306" y="7937"/>
+                  <a:pt x="1486" y="8060"/>
+                </a:cubicBezTo>
+                <a:cubicBezTo>
+                  <a:pt x="1482" y="8074"/>
+                  <a:pt x="1484" y="8088"/>
+                  <a:pt x="1490" y="8101"/>
+                </a:cubicBezTo>
+                <a:cubicBezTo>
+                  <a:pt x="1501" y="8119"/>
+                  <a:pt x="1507" y="8136"/>
+                  <a:pt x="1517" y="8152"/>
+                </a:cubicBezTo>
+                <a:cubicBezTo>
+                  <a:pt x="1513" y="8150"/>
+                  <a:pt x="1507" y="8148"/>
+                  <a:pt x="1501" y="8142"/>
+                </a:cubicBezTo>
+                <a:cubicBezTo>
+                  <a:pt x="1306" y="8027"/>
+                  <a:pt x="1124" y="7872"/>
+                  <a:pt x="991" y="7690"/>
+                </a:cubicBezTo>
+                <a:cubicBezTo>
+                  <a:pt x="983" y="7679"/>
+                  <a:pt x="969" y="7687"/>
+                  <a:pt x="973" y="7698"/>
+                </a:cubicBezTo>
+                <a:cubicBezTo>
+                  <a:pt x="1093" y="7884"/>
+                  <a:pt x="1249" y="8027"/>
+                  <a:pt x="1433" y="8152"/>
+                </a:cubicBezTo>
+                <a:cubicBezTo>
+                  <a:pt x="1474" y="8181"/>
+                  <a:pt x="1521" y="8209"/>
+                  <a:pt x="1566" y="8238"/>
+                </a:cubicBezTo>
+                <a:cubicBezTo>
+                  <a:pt x="2106" y="9107"/>
+                  <a:pt x="2790" y="8684"/>
+                  <a:pt x="2896" y="8608"/>
+                </a:cubicBezTo>
+                <a:cubicBezTo>
+                  <a:pt x="2943" y="8669"/>
+                  <a:pt x="2990" y="8731"/>
+                  <a:pt x="3041" y="8792"/>
+                </a:cubicBezTo>
+                <a:cubicBezTo>
+                  <a:pt x="3008" y="8784"/>
+                  <a:pt x="2976" y="8776"/>
+                  <a:pt x="2939" y="8772"/>
+                </a:cubicBezTo>
+                <a:cubicBezTo>
+                  <a:pt x="2693" y="8739"/>
+                  <a:pt x="2411" y="8802"/>
+                  <a:pt x="2090" y="8909"/>
+                </a:cubicBezTo>
+                <a:cubicBezTo>
+                  <a:pt x="2086" y="8913"/>
+                  <a:pt x="2084" y="8913"/>
+                  <a:pt x="2078" y="8915"/>
+                </a:cubicBezTo>
+                <a:cubicBezTo>
+                  <a:pt x="2037" y="8895"/>
+                  <a:pt x="1996" y="8874"/>
+                  <a:pt x="1955" y="8852"/>
+                </a:cubicBezTo>
+                <a:cubicBezTo>
+                  <a:pt x="1760" y="8735"/>
+                  <a:pt x="1578" y="8579"/>
+                  <a:pt x="1445" y="8397"/>
+                </a:cubicBezTo>
+                <a:cubicBezTo>
+                  <a:pt x="1439" y="8387"/>
+                  <a:pt x="1421" y="8397"/>
+                  <a:pt x="1429" y="8406"/>
+                </a:cubicBezTo>
+                <a:cubicBezTo>
+                  <a:pt x="1548" y="8592"/>
+                  <a:pt x="1705" y="8735"/>
+                  <a:pt x="1889" y="8862"/>
+                </a:cubicBezTo>
+                <a:cubicBezTo>
+                  <a:pt x="1941" y="8895"/>
+                  <a:pt x="1994" y="8929"/>
+                  <a:pt x="2053" y="8964"/>
+                </a:cubicBezTo>
+                <a:cubicBezTo>
+                  <a:pt x="2053" y="8974"/>
+                  <a:pt x="2057" y="8985"/>
+                  <a:pt x="2063" y="8991"/>
+                </a:cubicBezTo>
+                <a:cubicBezTo>
+                  <a:pt x="2088" y="9025"/>
+                  <a:pt x="2110" y="9056"/>
+                  <a:pt x="2137" y="9087"/>
+                </a:cubicBezTo>
+                <a:cubicBezTo>
+                  <a:pt x="2118" y="9079"/>
+                  <a:pt x="2104" y="9071"/>
+                  <a:pt x="2086" y="9060"/>
+                </a:cubicBezTo>
+                <a:cubicBezTo>
+                  <a:pt x="1885" y="8954"/>
+                  <a:pt x="1699" y="8805"/>
+                  <a:pt x="1558" y="8629"/>
+                </a:cubicBezTo>
+                <a:cubicBezTo>
+                  <a:pt x="1552" y="8618"/>
+                  <a:pt x="1535" y="8627"/>
+                  <a:pt x="1544" y="8637"/>
+                </a:cubicBezTo>
+                <a:cubicBezTo>
+                  <a:pt x="1670" y="8817"/>
+                  <a:pt x="1832" y="8954"/>
+                  <a:pt x="2022" y="9073"/>
+                </a:cubicBezTo>
+                <a:cubicBezTo>
+                  <a:pt x="2084" y="9113"/>
+                  <a:pt x="2155" y="9154"/>
+                  <a:pt x="2231" y="9191"/>
+                </a:cubicBezTo>
+                <a:cubicBezTo>
+                  <a:pt x="2816" y="9797"/>
+                  <a:pt x="3358" y="9441"/>
+                  <a:pt x="3516" y="9314"/>
+                </a:cubicBezTo>
+                <a:cubicBezTo>
+                  <a:pt x="3714" y="9510"/>
+                  <a:pt x="3929" y="9703"/>
+                  <a:pt x="4162" y="9885"/>
+                </a:cubicBezTo>
+                <a:cubicBezTo>
+                  <a:pt x="4185" y="9901"/>
+                  <a:pt x="4222" y="9897"/>
+                  <a:pt x="4242" y="9870"/>
+                </a:cubicBezTo>
+                <a:cubicBezTo>
+                  <a:pt x="4263" y="9846"/>
+                  <a:pt x="4267" y="9817"/>
+                  <a:pt x="4244" y="9799"/>
+                </a:cubicBezTo>
+                <a:close/>
+                <a:moveTo>
+                  <a:pt x="1210" y="4531"/>
+                </a:moveTo>
+                <a:cubicBezTo>
+                  <a:pt x="1204" y="4524"/>
+                  <a:pt x="1198" y="4514"/>
+                  <a:pt x="1190" y="4506"/>
+                </a:cubicBezTo>
+                <a:cubicBezTo>
+                  <a:pt x="1204" y="4508"/>
+                  <a:pt x="1214" y="4510"/>
+                  <a:pt x="1218" y="4514"/>
+                </a:cubicBezTo>
+                <a:cubicBezTo>
+                  <a:pt x="1216" y="4518"/>
+                  <a:pt x="1214" y="4526"/>
+                  <a:pt x="1210" y="4531"/>
+                </a:cubicBezTo>
+                <a:close/>
+                <a:moveTo>
+                  <a:pt x="2161" y="7145"/>
+                </a:moveTo>
+                <a:lnTo>
+                  <a:pt x="2161" y="7160"/>
+                </a:lnTo>
+                <a:cubicBezTo>
+                  <a:pt x="2159" y="7158"/>
+                  <a:pt x="2159" y="7151"/>
+                  <a:pt x="2157" y="7149"/>
+                </a:cubicBezTo>
+                <a:cubicBezTo>
+                  <a:pt x="2159" y="7147"/>
+                  <a:pt x="2161" y="7147"/>
+                  <a:pt x="2161" y="7145"/>
+                </a:cubicBezTo>
+                <a:close/>
+                <a:moveTo>
+                  <a:pt x="1883" y="7076"/>
+                </a:moveTo>
+                <a:cubicBezTo>
+                  <a:pt x="1914" y="7115"/>
+                  <a:pt x="1947" y="7149"/>
+                  <a:pt x="1986" y="7188"/>
+                </a:cubicBezTo>
+                <a:cubicBezTo>
+                  <a:pt x="1953" y="7174"/>
+                  <a:pt x="1916" y="7160"/>
+                  <a:pt x="1879" y="7147"/>
+                </a:cubicBezTo>
+                <a:cubicBezTo>
+                  <a:pt x="1834" y="7133"/>
+                  <a:pt x="1789" y="7119"/>
+                  <a:pt x="1740" y="7108"/>
+                </a:cubicBezTo>
+                <a:cubicBezTo>
+                  <a:pt x="1799" y="7098"/>
+                  <a:pt x="1848" y="7086"/>
+                  <a:pt x="1883" y="7076"/>
+                </a:cubicBezTo>
+                <a:close/>
+                <a:moveTo>
+                  <a:pt x="2526" y="7775"/>
+                </a:moveTo>
+                <a:cubicBezTo>
+                  <a:pt x="2548" y="7755"/>
+                  <a:pt x="2601" y="7700"/>
+                  <a:pt x="2667" y="7618"/>
+                </a:cubicBezTo>
+                <a:cubicBezTo>
+                  <a:pt x="2642" y="7698"/>
+                  <a:pt x="2628" y="7773"/>
+                  <a:pt x="2618" y="7849"/>
+                </a:cubicBezTo>
+                <a:cubicBezTo>
+                  <a:pt x="2612" y="7896"/>
+                  <a:pt x="2610" y="7945"/>
+                  <a:pt x="2612" y="7994"/>
+                </a:cubicBezTo>
+                <a:cubicBezTo>
+                  <a:pt x="2575" y="7935"/>
+                  <a:pt x="2538" y="7874"/>
+                  <a:pt x="2503" y="7814"/>
+                </a:cubicBezTo>
+                <a:cubicBezTo>
+                  <a:pt x="2517" y="7804"/>
+                  <a:pt x="2526" y="7790"/>
+                  <a:pt x="2526" y="7775"/>
+                </a:cubicBezTo>
+                <a:close/>
+                <a:moveTo>
+                  <a:pt x="3180" y="8342"/>
+                </a:moveTo>
+                <a:cubicBezTo>
+                  <a:pt x="3168" y="8424"/>
+                  <a:pt x="3162" y="8506"/>
+                  <a:pt x="3164" y="8582"/>
+                </a:cubicBezTo>
+                <a:cubicBezTo>
+                  <a:pt x="3168" y="8653"/>
+                  <a:pt x="3178" y="8725"/>
+                  <a:pt x="3195" y="8792"/>
+                </a:cubicBezTo>
+                <a:cubicBezTo>
+                  <a:pt x="3129" y="8712"/>
+                  <a:pt x="3062" y="8631"/>
+                  <a:pt x="3000" y="8549"/>
+                </a:cubicBezTo>
+                <a:cubicBezTo>
+                  <a:pt x="3047" y="8506"/>
+                  <a:pt x="3117" y="8436"/>
+                  <a:pt x="3180" y="8342"/>
+                </a:cubicBezTo>
+                <a:close/>
+              </a:path>
+            </a:pathLst>
+          </a:custGeom>
+          <a:solidFill>
+            <a:schemeClr val="dk1"/>
+          </a:solidFill>
+          <a:ln>
+            <a:noFill/>
+          </a:ln>
+        </p:spPr>
+        <p:txBody>
+          <a:bodyPr spcFirstLastPara="1" wrap="square" lIns="91425" tIns="91425" rIns="91425" bIns="91425" anchor="ctr" anchorCtr="0">
+            <a:noAutofit/>
+          </a:bodyPr>
+          <a:lstStyle/>
+          <a:p>
+            <a:pPr marL="0" lvl="0" indent="0" algn="l" rtl="0">
+              <a:spcBef>
+                <a:spcPts val="0"/>
+              </a:spcBef>
+              <a:spcAft>
+                <a:spcPts val="0"/>
+              </a:spcAft>
+              <a:buNone/>
+            </a:pPr>
+            <a:endParaRPr/>
+          </a:p>
+        </p:txBody>
+      </p:sp>
+      <p:sp>
+        <p:nvSpPr>
+          <p:cNvPr id="290" name="Google Shape;290;p37">
+            <a:extLst>
+              <a:ext uri="{FF2B5EF4-FFF2-40B4-BE49-F238E27FC236}">
+                <a16:creationId xmlns:a16="http://schemas.microsoft.com/office/drawing/2014/main" id="{6114B0A9-30F0-95B2-CB17-33C5407D995C}"/>
+              </a:ext>
+            </a:extLst>
+          </p:cNvPr>
+          <p:cNvSpPr/>
+          <p:nvPr/>
+        </p:nvSpPr>
+        <p:spPr>
+          <a:xfrm rot="-1571207">
+            <a:off x="5798542" y="3067279"/>
+            <a:ext cx="1067309" cy="2476818"/>
+          </a:xfrm>
+          <a:custGeom>
+            <a:avLst/>
+            <a:gdLst/>
+            <a:ahLst/>
+            <a:cxnLst/>
+            <a:rect l="l" t="t" r="r" b="b"/>
+            <a:pathLst>
+              <a:path w="4267" h="9902" extrusionOk="0">
+                <a:moveTo>
+                  <a:pt x="4244" y="9799"/>
+                </a:moveTo>
+                <a:cubicBezTo>
+                  <a:pt x="4017" y="9623"/>
+                  <a:pt x="3808" y="9439"/>
+                  <a:pt x="3614" y="9246"/>
+                </a:cubicBezTo>
+                <a:cubicBezTo>
+                  <a:pt x="3733" y="9122"/>
+                  <a:pt x="4203" y="8547"/>
+                  <a:pt x="3577" y="7829"/>
+                </a:cubicBezTo>
+                <a:cubicBezTo>
+                  <a:pt x="3569" y="7552"/>
+                  <a:pt x="3499" y="7280"/>
+                  <a:pt x="3383" y="7047"/>
+                </a:cubicBezTo>
+                <a:cubicBezTo>
+                  <a:pt x="3377" y="7041"/>
+                  <a:pt x="3362" y="7047"/>
+                  <a:pt x="3367" y="7057"/>
+                </a:cubicBezTo>
+                <a:cubicBezTo>
+                  <a:pt x="3459" y="7262"/>
+                  <a:pt x="3512" y="7475"/>
+                  <a:pt x="3528" y="7706"/>
+                </a:cubicBezTo>
+                <a:cubicBezTo>
+                  <a:pt x="3530" y="7728"/>
+                  <a:pt x="3530" y="7751"/>
+                  <a:pt x="3530" y="7773"/>
+                </a:cubicBezTo>
+                <a:cubicBezTo>
+                  <a:pt x="3506" y="7749"/>
+                  <a:pt x="3479" y="7720"/>
+                  <a:pt x="3450" y="7696"/>
+                </a:cubicBezTo>
+                <a:cubicBezTo>
+                  <a:pt x="3448" y="7692"/>
+                  <a:pt x="3444" y="7690"/>
+                  <a:pt x="3440" y="7687"/>
+                </a:cubicBezTo>
+                <a:cubicBezTo>
+                  <a:pt x="3409" y="7389"/>
+                  <a:pt x="3307" y="7098"/>
+                  <a:pt x="3150" y="6867"/>
+                </a:cubicBezTo>
+                <a:cubicBezTo>
+                  <a:pt x="3141" y="6857"/>
+                  <a:pt x="3127" y="6867"/>
+                  <a:pt x="3131" y="6877"/>
+                </a:cubicBezTo>
+                <a:cubicBezTo>
+                  <a:pt x="3244" y="7065"/>
+                  <a:pt x="3324" y="7272"/>
+                  <a:pt x="3367" y="7495"/>
+                </a:cubicBezTo>
+                <a:cubicBezTo>
+                  <a:pt x="3379" y="7559"/>
+                  <a:pt x="3385" y="7626"/>
+                  <a:pt x="3389" y="7692"/>
+                </a:cubicBezTo>
+                <a:cubicBezTo>
+                  <a:pt x="3387" y="7696"/>
+                  <a:pt x="3385" y="7698"/>
+                  <a:pt x="3383" y="7698"/>
+                </a:cubicBezTo>
+                <a:cubicBezTo>
+                  <a:pt x="3377" y="7700"/>
+                  <a:pt x="3375" y="7710"/>
+                  <a:pt x="3373" y="7714"/>
+                </a:cubicBezTo>
+                <a:cubicBezTo>
+                  <a:pt x="3364" y="7737"/>
+                  <a:pt x="3354" y="7759"/>
+                  <a:pt x="3346" y="7780"/>
+                </a:cubicBezTo>
+                <a:cubicBezTo>
+                  <a:pt x="3338" y="7559"/>
+                  <a:pt x="3254" y="7299"/>
+                  <a:pt x="3027" y="6998"/>
+                </a:cubicBezTo>
+                <a:lnTo>
+                  <a:pt x="3027" y="6998"/>
+                </a:lnTo>
+                <a:cubicBezTo>
+                  <a:pt x="3051" y="6738"/>
+                  <a:pt x="3029" y="6476"/>
+                  <a:pt x="2955" y="6241"/>
+                </a:cubicBezTo>
+                <a:cubicBezTo>
+                  <a:pt x="2953" y="6231"/>
+                  <a:pt x="2935" y="6237"/>
+                  <a:pt x="2937" y="6247"/>
+                </a:cubicBezTo>
+                <a:cubicBezTo>
+                  <a:pt x="2994" y="6466"/>
+                  <a:pt x="3011" y="6687"/>
+                  <a:pt x="2990" y="6920"/>
+                </a:cubicBezTo>
+                <a:lnTo>
+                  <a:pt x="2982" y="6982"/>
+                </a:lnTo>
+                <a:cubicBezTo>
+                  <a:pt x="2976" y="6982"/>
+                  <a:pt x="2966" y="6986"/>
+                  <a:pt x="2959" y="6994"/>
+                </a:cubicBezTo>
+                <a:cubicBezTo>
+                  <a:pt x="2951" y="6998"/>
+                  <a:pt x="2947" y="7006"/>
+                  <a:pt x="2945" y="7012"/>
+                </a:cubicBezTo>
+                <a:cubicBezTo>
+                  <a:pt x="2943" y="7014"/>
+                  <a:pt x="2943" y="7016"/>
+                  <a:pt x="2939" y="7023"/>
+                </a:cubicBezTo>
+                <a:cubicBezTo>
+                  <a:pt x="2996" y="6720"/>
+                  <a:pt x="2943" y="6347"/>
+                  <a:pt x="2620" y="5942"/>
+                </a:cubicBezTo>
+                <a:cubicBezTo>
+                  <a:pt x="2599" y="5713"/>
+                  <a:pt x="2538" y="5490"/>
+                  <a:pt x="2444" y="5296"/>
+                </a:cubicBezTo>
+                <a:cubicBezTo>
+                  <a:pt x="2436" y="5286"/>
+                  <a:pt x="2417" y="5292"/>
+                  <a:pt x="2423" y="5304"/>
+                </a:cubicBezTo>
+                <a:cubicBezTo>
+                  <a:pt x="2505" y="5498"/>
+                  <a:pt x="2556" y="5701"/>
+                  <a:pt x="2573" y="5916"/>
+                </a:cubicBezTo>
+                <a:cubicBezTo>
+                  <a:pt x="2560" y="5916"/>
+                  <a:pt x="2548" y="5922"/>
+                  <a:pt x="2536" y="5932"/>
+                </a:cubicBezTo>
+                <a:cubicBezTo>
+                  <a:pt x="2528" y="5940"/>
+                  <a:pt x="2522" y="5948"/>
+                  <a:pt x="2519" y="5957"/>
+                </a:cubicBezTo>
+                <a:cubicBezTo>
+                  <a:pt x="2517" y="5961"/>
+                  <a:pt x="2515" y="5967"/>
+                  <a:pt x="2511" y="5969"/>
+                </a:cubicBezTo>
+                <a:cubicBezTo>
+                  <a:pt x="2497" y="5717"/>
+                  <a:pt x="2436" y="5472"/>
+                  <a:pt x="2333" y="5263"/>
+                </a:cubicBezTo>
+                <a:cubicBezTo>
+                  <a:pt x="2325" y="5255"/>
+                  <a:pt x="2307" y="5261"/>
+                  <a:pt x="2313" y="5271"/>
+                </a:cubicBezTo>
+                <a:cubicBezTo>
+                  <a:pt x="2399" y="5478"/>
+                  <a:pt x="2454" y="5691"/>
+                  <a:pt x="2466" y="5920"/>
+                </a:cubicBezTo>
+                <a:cubicBezTo>
+                  <a:pt x="2468" y="5969"/>
+                  <a:pt x="2468" y="6018"/>
+                  <a:pt x="2466" y="6065"/>
+                </a:cubicBezTo>
+                <a:cubicBezTo>
+                  <a:pt x="2458" y="6083"/>
+                  <a:pt x="2448" y="6102"/>
+                  <a:pt x="2440" y="6120"/>
+                </a:cubicBezTo>
+                <a:cubicBezTo>
+                  <a:pt x="2405" y="5950"/>
+                  <a:pt x="2333" y="5766"/>
+                  <a:pt x="2209" y="5564"/>
+                </a:cubicBezTo>
+                <a:cubicBezTo>
+                  <a:pt x="2202" y="5554"/>
+                  <a:pt x="2192" y="5547"/>
+                  <a:pt x="2184" y="5543"/>
+                </a:cubicBezTo>
+                <a:cubicBezTo>
+                  <a:pt x="2239" y="5296"/>
+                  <a:pt x="2211" y="5030"/>
+                  <a:pt x="2090" y="4823"/>
+                </a:cubicBezTo>
+                <a:cubicBezTo>
+                  <a:pt x="2080" y="4813"/>
+                  <a:pt x="2065" y="4825"/>
+                  <a:pt x="2073" y="4835"/>
+                </a:cubicBezTo>
+                <a:cubicBezTo>
+                  <a:pt x="2168" y="5015"/>
+                  <a:pt x="2168" y="5200"/>
+                  <a:pt x="2153" y="5390"/>
+                </a:cubicBezTo>
+                <a:cubicBezTo>
+                  <a:pt x="2137" y="5234"/>
+                  <a:pt x="2088" y="5063"/>
+                  <a:pt x="2000" y="4874"/>
+                </a:cubicBezTo>
+                <a:cubicBezTo>
+                  <a:pt x="2100" y="4608"/>
+                  <a:pt x="2098" y="4295"/>
+                  <a:pt x="2133" y="4035"/>
+                </a:cubicBezTo>
+                <a:cubicBezTo>
+                  <a:pt x="2133" y="4025"/>
+                  <a:pt x="2121" y="4025"/>
+                  <a:pt x="2118" y="4033"/>
+                </a:cubicBezTo>
+                <a:cubicBezTo>
+                  <a:pt x="2082" y="4191"/>
+                  <a:pt x="2051" y="4351"/>
+                  <a:pt x="2026" y="4510"/>
+                </a:cubicBezTo>
+                <a:cubicBezTo>
+                  <a:pt x="2010" y="4608"/>
+                  <a:pt x="1986" y="4698"/>
+                  <a:pt x="1957" y="4784"/>
+                </a:cubicBezTo>
+                <a:cubicBezTo>
+                  <a:pt x="1953" y="4776"/>
+                  <a:pt x="1945" y="4770"/>
+                  <a:pt x="1936" y="4764"/>
+                </a:cubicBezTo>
+                <a:cubicBezTo>
+                  <a:pt x="2028" y="4459"/>
+                  <a:pt x="1973" y="4107"/>
+                  <a:pt x="1973" y="3804"/>
+                </a:cubicBezTo>
+                <a:cubicBezTo>
+                  <a:pt x="1971" y="3794"/>
+                  <a:pt x="1953" y="3794"/>
+                  <a:pt x="1953" y="3804"/>
+                </a:cubicBezTo>
+                <a:cubicBezTo>
+                  <a:pt x="1928" y="3956"/>
+                  <a:pt x="1936" y="4107"/>
+                  <a:pt x="1936" y="4256"/>
+                </a:cubicBezTo>
+                <a:lnTo>
+                  <a:pt x="1936" y="4291"/>
+                </a:lnTo>
+                <a:cubicBezTo>
+                  <a:pt x="1920" y="4164"/>
+                  <a:pt x="1883" y="4027"/>
+                  <a:pt x="1826" y="3878"/>
+                </a:cubicBezTo>
+                <a:cubicBezTo>
+                  <a:pt x="2078" y="3598"/>
+                  <a:pt x="2141" y="3127"/>
+                  <a:pt x="2188" y="2790"/>
+                </a:cubicBezTo>
+                <a:cubicBezTo>
+                  <a:pt x="2188" y="2777"/>
+                  <a:pt x="2168" y="2771"/>
+                  <a:pt x="2164" y="2785"/>
+                </a:cubicBezTo>
+                <a:cubicBezTo>
+                  <a:pt x="2086" y="3168"/>
+                  <a:pt x="1986" y="3504"/>
+                  <a:pt x="1781" y="3833"/>
+                </a:cubicBezTo>
+                <a:lnTo>
+                  <a:pt x="1779" y="3833"/>
+                </a:lnTo>
+                <a:cubicBezTo>
+                  <a:pt x="1801" y="3772"/>
+                  <a:pt x="1822" y="3702"/>
+                  <a:pt x="1836" y="3628"/>
+                </a:cubicBezTo>
+                <a:cubicBezTo>
+                  <a:pt x="1994" y="3371"/>
+                  <a:pt x="2000" y="3000"/>
+                  <a:pt x="2008" y="2730"/>
+                </a:cubicBezTo>
+                <a:cubicBezTo>
+                  <a:pt x="2010" y="2724"/>
+                  <a:pt x="1994" y="2724"/>
+                  <a:pt x="1990" y="2734"/>
+                </a:cubicBezTo>
+                <a:cubicBezTo>
+                  <a:pt x="1967" y="2974"/>
+                  <a:pt x="1934" y="3195"/>
+                  <a:pt x="1863" y="3409"/>
+                </a:cubicBezTo>
+                <a:cubicBezTo>
+                  <a:pt x="1867" y="3242"/>
+                  <a:pt x="1846" y="3053"/>
+                  <a:pt x="1785" y="2837"/>
+                </a:cubicBezTo>
+                <a:cubicBezTo>
+                  <a:pt x="1783" y="2826"/>
+                  <a:pt x="1779" y="2818"/>
+                  <a:pt x="1771" y="2810"/>
+                </a:cubicBezTo>
+                <a:cubicBezTo>
+                  <a:pt x="1789" y="2769"/>
+                  <a:pt x="1803" y="2726"/>
+                  <a:pt x="1820" y="2679"/>
+                </a:cubicBezTo>
+                <a:cubicBezTo>
+                  <a:pt x="1996" y="2407"/>
+                  <a:pt x="2037" y="2049"/>
+                  <a:pt x="2022" y="1744"/>
+                </a:cubicBezTo>
+                <a:cubicBezTo>
+                  <a:pt x="2022" y="1732"/>
+                  <a:pt x="2004" y="1734"/>
+                  <a:pt x="2004" y="1746"/>
+                </a:cubicBezTo>
+                <a:cubicBezTo>
+                  <a:pt x="2002" y="1936"/>
+                  <a:pt x="1981" y="2125"/>
+                  <a:pt x="1932" y="2311"/>
+                </a:cubicBezTo>
+                <a:cubicBezTo>
+                  <a:pt x="1914" y="2376"/>
+                  <a:pt x="1891" y="2434"/>
+                  <a:pt x="1865" y="2491"/>
+                </a:cubicBezTo>
+                <a:cubicBezTo>
+                  <a:pt x="1902" y="2284"/>
+                  <a:pt x="1895" y="2045"/>
+                  <a:pt x="1822" y="1773"/>
+                </a:cubicBezTo>
+                <a:cubicBezTo>
+                  <a:pt x="1981" y="1541"/>
+                  <a:pt x="2100" y="1267"/>
+                  <a:pt x="2151" y="1010"/>
+                </a:cubicBezTo>
+                <a:cubicBezTo>
+                  <a:pt x="2155" y="999"/>
+                  <a:pt x="2137" y="997"/>
+                  <a:pt x="2135" y="1008"/>
+                </a:cubicBezTo>
+                <a:cubicBezTo>
+                  <a:pt x="2055" y="1265"/>
+                  <a:pt x="1916" y="1482"/>
+                  <a:pt x="1783" y="1707"/>
+                </a:cubicBezTo>
+                <a:lnTo>
+                  <a:pt x="1781" y="1707"/>
+                </a:lnTo>
+                <a:cubicBezTo>
+                  <a:pt x="1875" y="1480"/>
+                  <a:pt x="1926" y="1222"/>
+                  <a:pt x="1920" y="991"/>
+                </a:cubicBezTo>
+                <a:cubicBezTo>
+                  <a:pt x="1916" y="985"/>
+                  <a:pt x="1902" y="985"/>
+                  <a:pt x="1902" y="995"/>
+                </a:cubicBezTo>
+                <a:cubicBezTo>
+                  <a:pt x="1883" y="1253"/>
+                  <a:pt x="1793" y="1482"/>
+                  <a:pt x="1717" y="1726"/>
+                </a:cubicBezTo>
+                <a:cubicBezTo>
+                  <a:pt x="1668" y="1767"/>
+                  <a:pt x="1623" y="1805"/>
+                  <a:pt x="1578" y="1842"/>
+                </a:cubicBezTo>
+                <a:cubicBezTo>
+                  <a:pt x="1638" y="1609"/>
+                  <a:pt x="1634" y="1306"/>
+                  <a:pt x="1476" y="934"/>
+                </a:cubicBezTo>
+                <a:cubicBezTo>
+                  <a:pt x="1554" y="654"/>
+                  <a:pt x="1615" y="381"/>
+                  <a:pt x="1760" y="109"/>
+                </a:cubicBezTo>
+                <a:cubicBezTo>
+                  <a:pt x="1767" y="97"/>
+                  <a:pt x="1750" y="89"/>
+                  <a:pt x="1742" y="99"/>
+                </a:cubicBezTo>
+                <a:cubicBezTo>
+                  <a:pt x="1599" y="308"/>
+                  <a:pt x="1486" y="570"/>
+                  <a:pt x="1425" y="827"/>
+                </a:cubicBezTo>
+                <a:cubicBezTo>
+                  <a:pt x="1411" y="815"/>
+                  <a:pt x="1388" y="813"/>
+                  <a:pt x="1364" y="825"/>
+                </a:cubicBezTo>
+                <a:cubicBezTo>
+                  <a:pt x="1362" y="825"/>
+                  <a:pt x="1362" y="827"/>
+                  <a:pt x="1359" y="827"/>
+                </a:cubicBezTo>
+                <a:cubicBezTo>
+                  <a:pt x="1433" y="555"/>
+                  <a:pt x="1494" y="285"/>
+                  <a:pt x="1638" y="23"/>
+                </a:cubicBezTo>
+                <a:cubicBezTo>
+                  <a:pt x="1644" y="13"/>
+                  <a:pt x="1625" y="1"/>
+                  <a:pt x="1619" y="15"/>
+                </a:cubicBezTo>
+                <a:cubicBezTo>
+                  <a:pt x="1441" y="273"/>
+                  <a:pt x="1310" y="611"/>
+                  <a:pt x="1267" y="928"/>
+                </a:cubicBezTo>
+                <a:cubicBezTo>
+                  <a:pt x="1065" y="1161"/>
+                  <a:pt x="924" y="1370"/>
+                  <a:pt x="856" y="1572"/>
+                </a:cubicBezTo>
+                <a:cubicBezTo>
+                  <a:pt x="805" y="1509"/>
+                  <a:pt x="748" y="1443"/>
+                  <a:pt x="688" y="1378"/>
+                </a:cubicBezTo>
+                <a:lnTo>
+                  <a:pt x="688" y="1378"/>
+                </a:lnTo>
+                <a:cubicBezTo>
+                  <a:pt x="678" y="1145"/>
+                  <a:pt x="686" y="915"/>
+                  <a:pt x="789" y="682"/>
+                </a:cubicBezTo>
+                <a:cubicBezTo>
+                  <a:pt x="797" y="672"/>
+                  <a:pt x="780" y="664"/>
+                  <a:pt x="774" y="674"/>
+                </a:cubicBezTo>
+                <a:cubicBezTo>
+                  <a:pt x="672" y="866"/>
+                  <a:pt x="611" y="1126"/>
+                  <a:pt x="611" y="1372"/>
+                </a:cubicBezTo>
+                <a:cubicBezTo>
+                  <a:pt x="605" y="1378"/>
+                  <a:pt x="600" y="1386"/>
+                  <a:pt x="596" y="1394"/>
+                </a:cubicBezTo>
+                <a:lnTo>
+                  <a:pt x="582" y="1431"/>
+                </a:lnTo>
+                <a:cubicBezTo>
+                  <a:pt x="543" y="1214"/>
+                  <a:pt x="541" y="997"/>
+                  <a:pt x="643" y="768"/>
+                </a:cubicBezTo>
+                <a:cubicBezTo>
+                  <a:pt x="645" y="764"/>
+                  <a:pt x="635" y="758"/>
+                  <a:pt x="631" y="766"/>
+                </a:cubicBezTo>
+                <a:cubicBezTo>
+                  <a:pt x="504" y="995"/>
+                  <a:pt x="484" y="1286"/>
+                  <a:pt x="539" y="1544"/>
+                </a:cubicBezTo>
+                <a:cubicBezTo>
+                  <a:pt x="355" y="2065"/>
+                  <a:pt x="390" y="2452"/>
+                  <a:pt x="508" y="2728"/>
+                </a:cubicBezTo>
+                <a:cubicBezTo>
+                  <a:pt x="492" y="2716"/>
+                  <a:pt x="474" y="2706"/>
+                  <a:pt x="457" y="2693"/>
+                </a:cubicBezTo>
+                <a:cubicBezTo>
+                  <a:pt x="451" y="2687"/>
+                  <a:pt x="443" y="2685"/>
+                  <a:pt x="437" y="2683"/>
+                </a:cubicBezTo>
+                <a:cubicBezTo>
+                  <a:pt x="422" y="2677"/>
+                  <a:pt x="408" y="2679"/>
+                  <a:pt x="398" y="2685"/>
+                </a:cubicBezTo>
+                <a:cubicBezTo>
+                  <a:pt x="328" y="2474"/>
+                  <a:pt x="279" y="2260"/>
+                  <a:pt x="267" y="2024"/>
+                </a:cubicBezTo>
+                <a:cubicBezTo>
+                  <a:pt x="265" y="2016"/>
+                  <a:pt x="253" y="2016"/>
+                  <a:pt x="253" y="2024"/>
+                </a:cubicBezTo>
+                <a:cubicBezTo>
+                  <a:pt x="244" y="2247"/>
+                  <a:pt x="277" y="2526"/>
+                  <a:pt x="357" y="2777"/>
+                </a:cubicBezTo>
+                <a:cubicBezTo>
+                  <a:pt x="246" y="3352"/>
+                  <a:pt x="345" y="3741"/>
+                  <a:pt x="504" y="3999"/>
+                </a:cubicBezTo>
+                <a:lnTo>
+                  <a:pt x="351" y="3923"/>
+                </a:lnTo>
+                <a:cubicBezTo>
+                  <a:pt x="347" y="3921"/>
+                  <a:pt x="339" y="3921"/>
+                  <a:pt x="330" y="3917"/>
+                </a:cubicBezTo>
+                <a:lnTo>
+                  <a:pt x="326" y="3917"/>
+                </a:lnTo>
+                <a:cubicBezTo>
+                  <a:pt x="144" y="3686"/>
+                  <a:pt x="30" y="3393"/>
+                  <a:pt x="38" y="3084"/>
+                </a:cubicBezTo>
+                <a:cubicBezTo>
+                  <a:pt x="38" y="3068"/>
+                  <a:pt x="17" y="3068"/>
+                  <a:pt x="17" y="3082"/>
+                </a:cubicBezTo>
+                <a:cubicBezTo>
+                  <a:pt x="1" y="3289"/>
+                  <a:pt x="58" y="3487"/>
+                  <a:pt x="132" y="3671"/>
+                </a:cubicBezTo>
+                <a:cubicBezTo>
+                  <a:pt x="165" y="3757"/>
+                  <a:pt x="212" y="3860"/>
+                  <a:pt x="269" y="3945"/>
+                </a:cubicBezTo>
+                <a:cubicBezTo>
+                  <a:pt x="267" y="3952"/>
+                  <a:pt x="265" y="3958"/>
+                  <a:pt x="265" y="3964"/>
+                </a:cubicBezTo>
+                <a:cubicBezTo>
+                  <a:pt x="206" y="4436"/>
+                  <a:pt x="316" y="4745"/>
+                  <a:pt x="482" y="4952"/>
+                </a:cubicBezTo>
+                <a:cubicBezTo>
+                  <a:pt x="478" y="4950"/>
+                  <a:pt x="469" y="4950"/>
+                  <a:pt x="463" y="4950"/>
+                </a:cubicBezTo>
+                <a:cubicBezTo>
+                  <a:pt x="449" y="4950"/>
+                  <a:pt x="437" y="4958"/>
+                  <a:pt x="429" y="4968"/>
+                </a:cubicBezTo>
+                <a:cubicBezTo>
+                  <a:pt x="396" y="4927"/>
+                  <a:pt x="361" y="4885"/>
+                  <a:pt x="330" y="4835"/>
+                </a:cubicBezTo>
+                <a:cubicBezTo>
+                  <a:pt x="244" y="4686"/>
+                  <a:pt x="171" y="4529"/>
+                  <a:pt x="89" y="4375"/>
+                </a:cubicBezTo>
+                <a:cubicBezTo>
+                  <a:pt x="85" y="4365"/>
+                  <a:pt x="73" y="4375"/>
+                  <a:pt x="75" y="4383"/>
+                </a:cubicBezTo>
+                <a:cubicBezTo>
+                  <a:pt x="173" y="4588"/>
+                  <a:pt x="259" y="4854"/>
+                  <a:pt x="408" y="5048"/>
+                </a:cubicBezTo>
+                <a:cubicBezTo>
+                  <a:pt x="422" y="5588"/>
+                  <a:pt x="596" y="5887"/>
+                  <a:pt x="805" y="6051"/>
+                </a:cubicBezTo>
+                <a:cubicBezTo>
+                  <a:pt x="766" y="6045"/>
+                  <a:pt x="725" y="6043"/>
+                  <a:pt x="686" y="6040"/>
+                </a:cubicBezTo>
+                <a:cubicBezTo>
+                  <a:pt x="551" y="5899"/>
+                  <a:pt x="433" y="5736"/>
+                  <a:pt x="330" y="5570"/>
+                </a:cubicBezTo>
+                <a:cubicBezTo>
+                  <a:pt x="324" y="5560"/>
+                  <a:pt x="308" y="5570"/>
+                  <a:pt x="316" y="5580"/>
+                </a:cubicBezTo>
+                <a:cubicBezTo>
+                  <a:pt x="388" y="5709"/>
+                  <a:pt x="482" y="5883"/>
+                  <a:pt x="602" y="6036"/>
+                </a:cubicBezTo>
+                <a:lnTo>
+                  <a:pt x="600" y="6036"/>
+                </a:lnTo>
+                <a:cubicBezTo>
+                  <a:pt x="600" y="6036"/>
+                  <a:pt x="596" y="6036"/>
+                  <a:pt x="596" y="6040"/>
+                </a:cubicBezTo>
+                <a:cubicBezTo>
+                  <a:pt x="576" y="6024"/>
+                  <a:pt x="560" y="6006"/>
+                  <a:pt x="539" y="5985"/>
+                </a:cubicBezTo>
+                <a:cubicBezTo>
+                  <a:pt x="392" y="5840"/>
+                  <a:pt x="269" y="5666"/>
+                  <a:pt x="161" y="5492"/>
+                </a:cubicBezTo>
+                <a:cubicBezTo>
+                  <a:pt x="152" y="5482"/>
+                  <a:pt x="140" y="5494"/>
+                  <a:pt x="144" y="5502"/>
+                </a:cubicBezTo>
+                <a:cubicBezTo>
+                  <a:pt x="238" y="5676"/>
+                  <a:pt x="377" y="5924"/>
+                  <a:pt x="555" y="6100"/>
+                </a:cubicBezTo>
+                <a:lnTo>
+                  <a:pt x="555" y="6110"/>
+                </a:lnTo>
+                <a:cubicBezTo>
+                  <a:pt x="686" y="6701"/>
+                  <a:pt x="958" y="6961"/>
+                  <a:pt x="1226" y="7059"/>
+                </a:cubicBezTo>
+                <a:cubicBezTo>
+                  <a:pt x="1114" y="7063"/>
+                  <a:pt x="999" y="7072"/>
+                  <a:pt x="877" y="7084"/>
+                </a:cubicBezTo>
+                <a:cubicBezTo>
+                  <a:pt x="870" y="7084"/>
+                  <a:pt x="862" y="7086"/>
+                  <a:pt x="858" y="7088"/>
+                </a:cubicBezTo>
+                <a:cubicBezTo>
+                  <a:pt x="697" y="6963"/>
+                  <a:pt x="551" y="6797"/>
+                  <a:pt x="451" y="6605"/>
+                </a:cubicBezTo>
+                <a:cubicBezTo>
+                  <a:pt x="447" y="6597"/>
+                  <a:pt x="431" y="6607"/>
+                  <a:pt x="437" y="6617"/>
+                </a:cubicBezTo>
+                <a:cubicBezTo>
+                  <a:pt x="523" y="6818"/>
+                  <a:pt x="652" y="6973"/>
+                  <a:pt x="805" y="7111"/>
+                </a:cubicBezTo>
+                <a:cubicBezTo>
+                  <a:pt x="811" y="7117"/>
+                  <a:pt x="817" y="7125"/>
+                  <a:pt x="825" y="7129"/>
+                </a:cubicBezTo>
+                <a:cubicBezTo>
+                  <a:pt x="821" y="7139"/>
+                  <a:pt x="825" y="7151"/>
+                  <a:pt x="830" y="7162"/>
+                </a:cubicBezTo>
+                <a:cubicBezTo>
+                  <a:pt x="1374" y="8181"/>
+                  <a:pt x="2131" y="7976"/>
+                  <a:pt x="2397" y="7861"/>
+                </a:cubicBezTo>
+                <a:cubicBezTo>
+                  <a:pt x="2436" y="7927"/>
+                  <a:pt x="2477" y="7994"/>
+                  <a:pt x="2517" y="8060"/>
+                </a:cubicBezTo>
+                <a:cubicBezTo>
+                  <a:pt x="2474" y="8039"/>
+                  <a:pt x="2425" y="8023"/>
+                  <a:pt x="2376" y="8007"/>
+                </a:cubicBezTo>
+                <a:cubicBezTo>
+                  <a:pt x="2141" y="7941"/>
+                  <a:pt x="1859" y="7962"/>
+                  <a:pt x="1527" y="8025"/>
+                </a:cubicBezTo>
+                <a:cubicBezTo>
+                  <a:pt x="1523" y="8025"/>
+                  <a:pt x="1517" y="8027"/>
+                  <a:pt x="1515" y="8027"/>
+                </a:cubicBezTo>
+                <a:cubicBezTo>
+                  <a:pt x="1339" y="7915"/>
+                  <a:pt x="1173" y="7769"/>
+                  <a:pt x="1051" y="7604"/>
+                </a:cubicBezTo>
+                <a:cubicBezTo>
+                  <a:pt x="1042" y="7593"/>
+                  <a:pt x="1026" y="7599"/>
+                  <a:pt x="1032" y="7610"/>
+                </a:cubicBezTo>
+                <a:cubicBezTo>
+                  <a:pt x="1153" y="7794"/>
+                  <a:pt x="1306" y="7937"/>
+                  <a:pt x="1486" y="8060"/>
+                </a:cubicBezTo>
+                <a:cubicBezTo>
+                  <a:pt x="1482" y="8074"/>
+                  <a:pt x="1484" y="8088"/>
+                  <a:pt x="1490" y="8101"/>
+                </a:cubicBezTo>
+                <a:cubicBezTo>
+                  <a:pt x="1501" y="8119"/>
+                  <a:pt x="1507" y="8136"/>
+                  <a:pt x="1517" y="8152"/>
+                </a:cubicBezTo>
+                <a:cubicBezTo>
+                  <a:pt x="1513" y="8150"/>
+                  <a:pt x="1507" y="8148"/>
+                  <a:pt x="1501" y="8142"/>
+                </a:cubicBezTo>
+                <a:cubicBezTo>
+                  <a:pt x="1306" y="8027"/>
+                  <a:pt x="1124" y="7872"/>
+                  <a:pt x="991" y="7690"/>
+                </a:cubicBezTo>
+                <a:cubicBezTo>
+                  <a:pt x="983" y="7679"/>
+                  <a:pt x="969" y="7687"/>
+                  <a:pt x="973" y="7698"/>
+                </a:cubicBezTo>
+                <a:cubicBezTo>
+                  <a:pt x="1093" y="7884"/>
+                  <a:pt x="1249" y="8027"/>
+                  <a:pt x="1433" y="8152"/>
+                </a:cubicBezTo>
+                <a:cubicBezTo>
+                  <a:pt x="1474" y="8181"/>
+                  <a:pt x="1521" y="8209"/>
+                  <a:pt x="1566" y="8238"/>
+                </a:cubicBezTo>
+                <a:cubicBezTo>
+                  <a:pt x="2106" y="9107"/>
+                  <a:pt x="2790" y="8684"/>
+                  <a:pt x="2896" y="8608"/>
+                </a:cubicBezTo>
+                <a:cubicBezTo>
+                  <a:pt x="2943" y="8669"/>
+                  <a:pt x="2990" y="8731"/>
+                  <a:pt x="3041" y="8792"/>
+                </a:cubicBezTo>
+                <a:cubicBezTo>
+                  <a:pt x="3008" y="8784"/>
+                  <a:pt x="2976" y="8776"/>
+                  <a:pt x="2939" y="8772"/>
+                </a:cubicBezTo>
+                <a:cubicBezTo>
+                  <a:pt x="2693" y="8739"/>
+                  <a:pt x="2411" y="8802"/>
+                  <a:pt x="2090" y="8909"/>
+                </a:cubicBezTo>
+                <a:cubicBezTo>
+                  <a:pt x="2086" y="8913"/>
+                  <a:pt x="2084" y="8913"/>
+                  <a:pt x="2078" y="8915"/>
+                </a:cubicBezTo>
+                <a:cubicBezTo>
+                  <a:pt x="2037" y="8895"/>
+                  <a:pt x="1996" y="8874"/>
+                  <a:pt x="1955" y="8852"/>
+                </a:cubicBezTo>
+                <a:cubicBezTo>
+                  <a:pt x="1760" y="8735"/>
+                  <a:pt x="1578" y="8579"/>
+                  <a:pt x="1445" y="8397"/>
+                </a:cubicBezTo>
+                <a:cubicBezTo>
+                  <a:pt x="1439" y="8387"/>
+                  <a:pt x="1421" y="8397"/>
+                  <a:pt x="1429" y="8406"/>
+                </a:cubicBezTo>
+                <a:cubicBezTo>
+                  <a:pt x="1548" y="8592"/>
+                  <a:pt x="1705" y="8735"/>
+                  <a:pt x="1889" y="8862"/>
+                </a:cubicBezTo>
+                <a:cubicBezTo>
+                  <a:pt x="1941" y="8895"/>
+                  <a:pt x="1994" y="8929"/>
+                  <a:pt x="2053" y="8964"/>
+                </a:cubicBezTo>
+                <a:cubicBezTo>
+                  <a:pt x="2053" y="8974"/>
+                  <a:pt x="2057" y="8985"/>
+                  <a:pt x="2063" y="8991"/>
+                </a:cubicBezTo>
+                <a:cubicBezTo>
+                  <a:pt x="2088" y="9025"/>
+                  <a:pt x="2110" y="9056"/>
+                  <a:pt x="2137" y="9087"/>
+                </a:cubicBezTo>
+                <a:cubicBezTo>
+                  <a:pt x="2118" y="9079"/>
+                  <a:pt x="2104" y="9071"/>
+                  <a:pt x="2086" y="9060"/>
+                </a:cubicBezTo>
+                <a:cubicBezTo>
+                  <a:pt x="1885" y="8954"/>
+                  <a:pt x="1699" y="8805"/>
+                  <a:pt x="1558" y="8629"/>
+                </a:cubicBezTo>
+                <a:cubicBezTo>
+                  <a:pt x="1552" y="8618"/>
+                  <a:pt x="1535" y="8627"/>
+                  <a:pt x="1544" y="8637"/>
+                </a:cubicBezTo>
+                <a:cubicBezTo>
+                  <a:pt x="1670" y="8817"/>
+                  <a:pt x="1832" y="8954"/>
+                  <a:pt x="2022" y="9073"/>
+                </a:cubicBezTo>
+                <a:cubicBezTo>
+                  <a:pt x="2084" y="9113"/>
+                  <a:pt x="2155" y="9154"/>
+                  <a:pt x="2231" y="9191"/>
+                </a:cubicBezTo>
+                <a:cubicBezTo>
+                  <a:pt x="2816" y="9797"/>
+                  <a:pt x="3358" y="9441"/>
+                  <a:pt x="3516" y="9314"/>
+                </a:cubicBezTo>
+                <a:cubicBezTo>
+                  <a:pt x="3714" y="9510"/>
+                  <a:pt x="3929" y="9703"/>
+                  <a:pt x="4162" y="9885"/>
+                </a:cubicBezTo>
+                <a:cubicBezTo>
+                  <a:pt x="4185" y="9901"/>
+                  <a:pt x="4222" y="9897"/>
+                  <a:pt x="4242" y="9870"/>
+                </a:cubicBezTo>
+                <a:cubicBezTo>
+                  <a:pt x="4263" y="9846"/>
+                  <a:pt x="4267" y="9817"/>
+                  <a:pt x="4244" y="9799"/>
+                </a:cubicBezTo>
+                <a:close/>
+                <a:moveTo>
+                  <a:pt x="1210" y="4531"/>
+                </a:moveTo>
+                <a:cubicBezTo>
+                  <a:pt x="1204" y="4524"/>
+                  <a:pt x="1198" y="4514"/>
+                  <a:pt x="1190" y="4506"/>
+                </a:cubicBezTo>
+                <a:cubicBezTo>
+                  <a:pt x="1204" y="4508"/>
+                  <a:pt x="1214" y="4510"/>
+                  <a:pt x="1218" y="4514"/>
+                </a:cubicBezTo>
+                <a:cubicBezTo>
+                  <a:pt x="1216" y="4518"/>
+                  <a:pt x="1214" y="4526"/>
+                  <a:pt x="1210" y="4531"/>
+                </a:cubicBezTo>
+                <a:close/>
+                <a:moveTo>
+                  <a:pt x="2161" y="7145"/>
+                </a:moveTo>
+                <a:lnTo>
+                  <a:pt x="2161" y="7160"/>
+                </a:lnTo>
+                <a:cubicBezTo>
+                  <a:pt x="2159" y="7158"/>
+                  <a:pt x="2159" y="7151"/>
+                  <a:pt x="2157" y="7149"/>
+                </a:cubicBezTo>
+                <a:cubicBezTo>
+                  <a:pt x="2159" y="7147"/>
+                  <a:pt x="2161" y="7147"/>
+                  <a:pt x="2161" y="7145"/>
+                </a:cubicBezTo>
+                <a:close/>
+                <a:moveTo>
+                  <a:pt x="1883" y="7076"/>
+                </a:moveTo>
+                <a:cubicBezTo>
+                  <a:pt x="1914" y="7115"/>
+                  <a:pt x="1947" y="7149"/>
+                  <a:pt x="1986" y="7188"/>
+                </a:cubicBezTo>
+                <a:cubicBezTo>
+                  <a:pt x="1953" y="7174"/>
+                  <a:pt x="1916" y="7160"/>
+                  <a:pt x="1879" y="7147"/>
+                </a:cubicBezTo>
+                <a:cubicBezTo>
+                  <a:pt x="1834" y="7133"/>
+                  <a:pt x="1789" y="7119"/>
+                  <a:pt x="1740" y="7108"/>
+                </a:cubicBezTo>
+                <a:cubicBezTo>
+                  <a:pt x="1799" y="7098"/>
+                  <a:pt x="1848" y="7086"/>
+                  <a:pt x="1883" y="7076"/>
+                </a:cubicBezTo>
+                <a:close/>
+                <a:moveTo>
+                  <a:pt x="2526" y="7775"/>
+                </a:moveTo>
+                <a:cubicBezTo>
+                  <a:pt x="2548" y="7755"/>
+                  <a:pt x="2601" y="7700"/>
+                  <a:pt x="2667" y="7618"/>
+                </a:cubicBezTo>
+                <a:cubicBezTo>
+                  <a:pt x="2642" y="7698"/>
+                  <a:pt x="2628" y="7773"/>
+                  <a:pt x="2618" y="7849"/>
+                </a:cubicBezTo>
+                <a:cubicBezTo>
+                  <a:pt x="2612" y="7896"/>
+                  <a:pt x="2610" y="7945"/>
+                  <a:pt x="2612" y="7994"/>
+                </a:cubicBezTo>
+                <a:cubicBezTo>
+                  <a:pt x="2575" y="7935"/>
+                  <a:pt x="2538" y="7874"/>
+                  <a:pt x="2503" y="7814"/>
+                </a:cubicBezTo>
+                <a:cubicBezTo>
+                  <a:pt x="2517" y="7804"/>
+                  <a:pt x="2526" y="7790"/>
+                  <a:pt x="2526" y="7775"/>
+                </a:cubicBezTo>
+                <a:close/>
+                <a:moveTo>
+                  <a:pt x="3180" y="8342"/>
+                </a:moveTo>
+                <a:cubicBezTo>
+                  <a:pt x="3168" y="8424"/>
+                  <a:pt x="3162" y="8506"/>
+                  <a:pt x="3164" y="8582"/>
+                </a:cubicBezTo>
+                <a:cubicBezTo>
+                  <a:pt x="3168" y="8653"/>
+                  <a:pt x="3178" y="8725"/>
+                  <a:pt x="3195" y="8792"/>
+                </a:cubicBezTo>
+                <a:cubicBezTo>
+                  <a:pt x="3129" y="8712"/>
+                  <a:pt x="3062" y="8631"/>
+                  <a:pt x="3000" y="8549"/>
+                </a:cubicBezTo>
+                <a:cubicBezTo>
+                  <a:pt x="3047" y="8506"/>
+                  <a:pt x="3117" y="8436"/>
+                  <a:pt x="3180" y="8342"/>
+                </a:cubicBezTo>
+                <a:close/>
+              </a:path>
+            </a:pathLst>
+          </a:custGeom>
+          <a:solidFill>
+            <a:schemeClr val="dk1"/>
+          </a:solidFill>
+          <a:ln>
+            <a:noFill/>
+          </a:ln>
+        </p:spPr>
+        <p:txBody>
+          <a:bodyPr spcFirstLastPara="1" wrap="square" lIns="91425" tIns="91425" rIns="91425" bIns="91425" anchor="ctr" anchorCtr="0">
+            <a:noAutofit/>
+          </a:bodyPr>
+          <a:lstStyle/>
+          <a:p>
+            <a:pPr marL="0" lvl="0" indent="0" algn="l" rtl="0">
+              <a:spcBef>
+                <a:spcPts val="0"/>
+              </a:spcBef>
+              <a:spcAft>
+                <a:spcPts val="0"/>
+              </a:spcAft>
+              <a:buNone/>
+            </a:pPr>
+            <a:endParaRPr/>
+          </a:p>
+        </p:txBody>
+      </p:sp>
+      <p:pic>
+        <p:nvPicPr>
+          <p:cNvPr id="291" name="Google Shape;291;p37">
+            <a:extLst>
+              <a:ext uri="{FF2B5EF4-FFF2-40B4-BE49-F238E27FC236}">
+                <a16:creationId xmlns:a16="http://schemas.microsoft.com/office/drawing/2014/main" id="{02CEB610-1A97-6A4D-D768-048D1DC67059}"/>
+              </a:ext>
+            </a:extLst>
+          </p:cNvPr>
+          <p:cNvPicPr preferRelativeResize="0"/>
+          <p:nvPr/>
+        </p:nvPicPr>
+        <p:blipFill>
+          <a:blip r:embed="rId7">
+            <a:alphaModFix/>
+          </a:blip>
+          <a:stretch>
+            <a:fillRect/>
+          </a:stretch>
+        </p:blipFill>
+        <p:spPr>
+          <a:xfrm rot="-865630">
+            <a:off x="6096513" y="2296787"/>
+            <a:ext cx="2602346" cy="3539729"/>
+          </a:xfrm>
+          <a:prstGeom prst="rect">
+            <a:avLst/>
+          </a:prstGeom>
+          <a:noFill/>
+          <a:ln>
+            <a:noFill/>
+          </a:ln>
+        </p:spPr>
+      </p:pic>
+      <p:sp>
+        <p:nvSpPr>
+          <p:cNvPr id="292" name="Google Shape;292;p37">
+            <a:extLst>
+              <a:ext uri="{FF2B5EF4-FFF2-40B4-BE49-F238E27FC236}">
+                <a16:creationId xmlns:a16="http://schemas.microsoft.com/office/drawing/2014/main" id="{5CFEF18F-8A82-1976-1972-4085521EBF44}"/>
+              </a:ext>
+            </a:extLst>
+          </p:cNvPr>
+          <p:cNvSpPr/>
+          <p:nvPr/>
+        </p:nvSpPr>
+        <p:spPr>
+          <a:xfrm rot="-2051766">
+            <a:off x="5580704" y="3464444"/>
+            <a:ext cx="1067306" cy="2476831"/>
+          </a:xfrm>
+          <a:custGeom>
+            <a:avLst/>
+            <a:gdLst/>
+            <a:ahLst/>
+            <a:cxnLst/>
+            <a:rect l="l" t="t" r="r" b="b"/>
+            <a:pathLst>
+              <a:path w="4267" h="9902" extrusionOk="0">
+                <a:moveTo>
+                  <a:pt x="4244" y="9799"/>
+                </a:moveTo>
+                <a:cubicBezTo>
+                  <a:pt x="4017" y="9623"/>
+                  <a:pt x="3808" y="9439"/>
+                  <a:pt x="3614" y="9246"/>
+                </a:cubicBezTo>
+                <a:cubicBezTo>
+                  <a:pt x="3733" y="9122"/>
+                  <a:pt x="4203" y="8547"/>
+                  <a:pt x="3577" y="7829"/>
+                </a:cubicBezTo>
+                <a:cubicBezTo>
+                  <a:pt x="3569" y="7552"/>
+                  <a:pt x="3499" y="7280"/>
+                  <a:pt x="3383" y="7047"/>
+                </a:cubicBezTo>
+                <a:cubicBezTo>
+                  <a:pt x="3377" y="7041"/>
+                  <a:pt x="3362" y="7047"/>
+                  <a:pt x="3367" y="7057"/>
+                </a:cubicBezTo>
+                <a:cubicBezTo>
+                  <a:pt x="3459" y="7262"/>
+                  <a:pt x="3512" y="7475"/>
+                  <a:pt x="3528" y="7706"/>
+                </a:cubicBezTo>
+                <a:cubicBezTo>
+                  <a:pt x="3530" y="7728"/>
+                  <a:pt x="3530" y="7751"/>
+                  <a:pt x="3530" y="7773"/>
+                </a:cubicBezTo>
+                <a:cubicBezTo>
+                  <a:pt x="3506" y="7749"/>
+                  <a:pt x="3479" y="7720"/>
+                  <a:pt x="3450" y="7696"/>
+                </a:cubicBezTo>
+                <a:cubicBezTo>
+                  <a:pt x="3448" y="7692"/>
+                  <a:pt x="3444" y="7690"/>
+                  <a:pt x="3440" y="7687"/>
+                </a:cubicBezTo>
+                <a:cubicBezTo>
+                  <a:pt x="3409" y="7389"/>
+                  <a:pt x="3307" y="7098"/>
+                  <a:pt x="3150" y="6867"/>
+                </a:cubicBezTo>
+                <a:cubicBezTo>
+                  <a:pt x="3141" y="6857"/>
+                  <a:pt x="3127" y="6867"/>
+                  <a:pt x="3131" y="6877"/>
+                </a:cubicBezTo>
+                <a:cubicBezTo>
+                  <a:pt x="3244" y="7065"/>
+                  <a:pt x="3324" y="7272"/>
+                  <a:pt x="3367" y="7495"/>
+                </a:cubicBezTo>
+                <a:cubicBezTo>
+                  <a:pt x="3379" y="7559"/>
+                  <a:pt x="3385" y="7626"/>
+                  <a:pt x="3389" y="7692"/>
+                </a:cubicBezTo>
+                <a:cubicBezTo>
+                  <a:pt x="3387" y="7696"/>
+                  <a:pt x="3385" y="7698"/>
+                  <a:pt x="3383" y="7698"/>
+                </a:cubicBezTo>
+                <a:cubicBezTo>
+                  <a:pt x="3377" y="7700"/>
+                  <a:pt x="3375" y="7710"/>
+                  <a:pt x="3373" y="7714"/>
+                </a:cubicBezTo>
+                <a:cubicBezTo>
+                  <a:pt x="3364" y="7737"/>
+                  <a:pt x="3354" y="7759"/>
+                  <a:pt x="3346" y="7780"/>
+                </a:cubicBezTo>
+                <a:cubicBezTo>
+                  <a:pt x="3338" y="7559"/>
+                  <a:pt x="3254" y="7299"/>
+                  <a:pt x="3027" y="6998"/>
+                </a:cubicBezTo>
+                <a:lnTo>
+                  <a:pt x="3027" y="6998"/>
+                </a:lnTo>
+                <a:cubicBezTo>
+                  <a:pt x="3051" y="6738"/>
+                  <a:pt x="3029" y="6476"/>
+                  <a:pt x="2955" y="6241"/>
+                </a:cubicBezTo>
+                <a:cubicBezTo>
+                  <a:pt x="2953" y="6231"/>
+                  <a:pt x="2935" y="6237"/>
+                  <a:pt x="2937" y="6247"/>
+                </a:cubicBezTo>
+                <a:cubicBezTo>
+                  <a:pt x="2994" y="6466"/>
+                  <a:pt x="3011" y="6687"/>
+                  <a:pt x="2990" y="6920"/>
+                </a:cubicBezTo>
+                <a:lnTo>
+                  <a:pt x="2982" y="6982"/>
+                </a:lnTo>
+                <a:cubicBezTo>
+                  <a:pt x="2976" y="6982"/>
+                  <a:pt x="2966" y="6986"/>
+                  <a:pt x="2959" y="6994"/>
+                </a:cubicBezTo>
+                <a:cubicBezTo>
+                  <a:pt x="2951" y="6998"/>
+                  <a:pt x="2947" y="7006"/>
+                  <a:pt x="2945" y="7012"/>
+                </a:cubicBezTo>
+                <a:cubicBezTo>
+                  <a:pt x="2943" y="7014"/>
+                  <a:pt x="2943" y="7016"/>
+                  <a:pt x="2939" y="7023"/>
+                </a:cubicBezTo>
+                <a:cubicBezTo>
+                  <a:pt x="2996" y="6720"/>
+                  <a:pt x="2943" y="6347"/>
+                  <a:pt x="2620" y="5942"/>
+                </a:cubicBezTo>
+                <a:cubicBezTo>
+                  <a:pt x="2599" y="5713"/>
+                  <a:pt x="2538" y="5490"/>
+                  <a:pt x="2444" y="5296"/>
+                </a:cubicBezTo>
+                <a:cubicBezTo>
+                  <a:pt x="2436" y="5286"/>
+                  <a:pt x="2417" y="5292"/>
+                  <a:pt x="2423" y="5304"/>
+                </a:cubicBezTo>
+                <a:cubicBezTo>
+                  <a:pt x="2505" y="5498"/>
+                  <a:pt x="2556" y="5701"/>
+                  <a:pt x="2573" y="5916"/>
+                </a:cubicBezTo>
+                <a:cubicBezTo>
+                  <a:pt x="2560" y="5916"/>
+                  <a:pt x="2548" y="5922"/>
+                  <a:pt x="2536" y="5932"/>
+                </a:cubicBezTo>
+                <a:cubicBezTo>
+                  <a:pt x="2528" y="5940"/>
+                  <a:pt x="2522" y="5948"/>
+                  <a:pt x="2519" y="5957"/>
+                </a:cubicBezTo>
+                <a:cubicBezTo>
+                  <a:pt x="2517" y="5961"/>
+                  <a:pt x="2515" y="5967"/>
+                  <a:pt x="2511" y="5969"/>
+                </a:cubicBezTo>
+                <a:cubicBezTo>
+                  <a:pt x="2497" y="5717"/>
+                  <a:pt x="2436" y="5472"/>
+                  <a:pt x="2333" y="5263"/>
+                </a:cubicBezTo>
+                <a:cubicBezTo>
+                  <a:pt x="2325" y="5255"/>
+                  <a:pt x="2307" y="5261"/>
+                  <a:pt x="2313" y="5271"/>
+                </a:cubicBezTo>
+                <a:cubicBezTo>
+                  <a:pt x="2399" y="5478"/>
+                  <a:pt x="2454" y="5691"/>
+                  <a:pt x="2466" y="5920"/>
+                </a:cubicBezTo>
+                <a:cubicBezTo>
+                  <a:pt x="2468" y="5969"/>
+                  <a:pt x="2468" y="6018"/>
+                  <a:pt x="2466" y="6065"/>
+                </a:cubicBezTo>
+                <a:cubicBezTo>
+                  <a:pt x="2458" y="6083"/>
+                  <a:pt x="2448" y="6102"/>
+                  <a:pt x="2440" y="6120"/>
+                </a:cubicBezTo>
+                <a:cubicBezTo>
+                  <a:pt x="2405" y="5950"/>
+                  <a:pt x="2333" y="5766"/>
+                  <a:pt x="2209" y="5564"/>
+                </a:cubicBezTo>
+                <a:cubicBezTo>
+                  <a:pt x="2202" y="5554"/>
+                  <a:pt x="2192" y="5547"/>
+                  <a:pt x="2184" y="5543"/>
+                </a:cubicBezTo>
+                <a:cubicBezTo>
+                  <a:pt x="2239" y="5296"/>
+                  <a:pt x="2211" y="5030"/>
+                  <a:pt x="2090" y="4823"/>
+                </a:cubicBezTo>
+                <a:cubicBezTo>
+                  <a:pt x="2080" y="4813"/>
+                  <a:pt x="2065" y="4825"/>
+                  <a:pt x="2073" y="4835"/>
+                </a:cubicBezTo>
+                <a:cubicBezTo>
+                  <a:pt x="2168" y="5015"/>
+                  <a:pt x="2168" y="5200"/>
+                  <a:pt x="2153" y="5390"/>
+                </a:cubicBezTo>
+                <a:cubicBezTo>
+                  <a:pt x="2137" y="5234"/>
+                  <a:pt x="2088" y="5063"/>
+                  <a:pt x="2000" y="4874"/>
+                </a:cubicBezTo>
+                <a:cubicBezTo>
+                  <a:pt x="2100" y="4608"/>
+                  <a:pt x="2098" y="4295"/>
+                  <a:pt x="2133" y="4035"/>
+                </a:cubicBezTo>
+                <a:cubicBezTo>
+                  <a:pt x="2133" y="4025"/>
+                  <a:pt x="2121" y="4025"/>
+                  <a:pt x="2118" y="4033"/>
+                </a:cubicBezTo>
+                <a:cubicBezTo>
+                  <a:pt x="2082" y="4191"/>
+                  <a:pt x="2051" y="4351"/>
+                  <a:pt x="2026" y="4510"/>
+                </a:cubicBezTo>
+                <a:cubicBezTo>
+                  <a:pt x="2010" y="4608"/>
+                  <a:pt x="1986" y="4698"/>
+                  <a:pt x="1957" y="4784"/>
+                </a:cubicBezTo>
+                <a:cubicBezTo>
+                  <a:pt x="1953" y="4776"/>
+                  <a:pt x="1945" y="4770"/>
+                  <a:pt x="1936" y="4764"/>
+                </a:cubicBezTo>
+                <a:cubicBezTo>
+                  <a:pt x="2028" y="4459"/>
+                  <a:pt x="1973" y="4107"/>
+                  <a:pt x="1973" y="3804"/>
+                </a:cubicBezTo>
+                <a:cubicBezTo>
+                  <a:pt x="1971" y="3794"/>
+                  <a:pt x="1953" y="3794"/>
+                  <a:pt x="1953" y="3804"/>
+                </a:cubicBezTo>
+                <a:cubicBezTo>
+                  <a:pt x="1928" y="3956"/>
+                  <a:pt x="1936" y="4107"/>
+                  <a:pt x="1936" y="4256"/>
+                </a:cubicBezTo>
+                <a:lnTo>
+                  <a:pt x="1936" y="4291"/>
+                </a:lnTo>
+                <a:cubicBezTo>
+                  <a:pt x="1920" y="4164"/>
+                  <a:pt x="1883" y="4027"/>
+                  <a:pt x="1826" y="3878"/>
+                </a:cubicBezTo>
+                <a:cubicBezTo>
+                  <a:pt x="2078" y="3598"/>
+                  <a:pt x="2141" y="3127"/>
+                  <a:pt x="2188" y="2790"/>
+                </a:cubicBezTo>
+                <a:cubicBezTo>
+                  <a:pt x="2188" y="2777"/>
+                  <a:pt x="2168" y="2771"/>
+                  <a:pt x="2164" y="2785"/>
+                </a:cubicBezTo>
+                <a:cubicBezTo>
+                  <a:pt x="2086" y="3168"/>
+                  <a:pt x="1986" y="3504"/>
+                  <a:pt x="1781" y="3833"/>
+                </a:cubicBezTo>
+                <a:lnTo>
+                  <a:pt x="1779" y="3833"/>
+                </a:lnTo>
+                <a:cubicBezTo>
+                  <a:pt x="1801" y="3772"/>
+                  <a:pt x="1822" y="3702"/>
+                  <a:pt x="1836" y="3628"/>
+                </a:cubicBezTo>
+                <a:cubicBezTo>
+                  <a:pt x="1994" y="3371"/>
+                  <a:pt x="2000" y="3000"/>
+                  <a:pt x="2008" y="2730"/>
+                </a:cubicBezTo>
+                <a:cubicBezTo>
+                  <a:pt x="2010" y="2724"/>
+                  <a:pt x="1994" y="2724"/>
+                  <a:pt x="1990" y="2734"/>
+                </a:cubicBezTo>
+                <a:cubicBezTo>
+                  <a:pt x="1967" y="2974"/>
+                  <a:pt x="1934" y="3195"/>
+                  <a:pt x="1863" y="3409"/>
+                </a:cubicBezTo>
+                <a:cubicBezTo>
+                  <a:pt x="1867" y="3242"/>
+                  <a:pt x="1846" y="3053"/>
+                  <a:pt x="1785" y="2837"/>
+                </a:cubicBezTo>
+                <a:cubicBezTo>
+                  <a:pt x="1783" y="2826"/>
+                  <a:pt x="1779" y="2818"/>
+                  <a:pt x="1771" y="2810"/>
+                </a:cubicBezTo>
+                <a:cubicBezTo>
+                  <a:pt x="1789" y="2769"/>
+                  <a:pt x="1803" y="2726"/>
+                  <a:pt x="1820" y="2679"/>
+                </a:cubicBezTo>
+                <a:cubicBezTo>
+                  <a:pt x="1996" y="2407"/>
+                  <a:pt x="2037" y="2049"/>
+                  <a:pt x="2022" y="1744"/>
+                </a:cubicBezTo>
+                <a:cubicBezTo>
+                  <a:pt x="2022" y="1732"/>
+                  <a:pt x="2004" y="1734"/>
+                  <a:pt x="2004" y="1746"/>
+                </a:cubicBezTo>
+                <a:cubicBezTo>
+                  <a:pt x="2002" y="1936"/>
+                  <a:pt x="1981" y="2125"/>
+                  <a:pt x="1932" y="2311"/>
+                </a:cubicBezTo>
+                <a:cubicBezTo>
+                  <a:pt x="1914" y="2376"/>
+                  <a:pt x="1891" y="2434"/>
+                  <a:pt x="1865" y="2491"/>
+                </a:cubicBezTo>
+                <a:cubicBezTo>
+                  <a:pt x="1902" y="2284"/>
+                  <a:pt x="1895" y="2045"/>
+                  <a:pt x="1822" y="1773"/>
+                </a:cubicBezTo>
+                <a:cubicBezTo>
+                  <a:pt x="1981" y="1541"/>
+                  <a:pt x="2100" y="1267"/>
+                  <a:pt x="2151" y="1010"/>
+                </a:cubicBezTo>
+                <a:cubicBezTo>
+                  <a:pt x="2155" y="999"/>
+                  <a:pt x="2137" y="997"/>
+                  <a:pt x="2135" y="1008"/>
+                </a:cubicBezTo>
+                <a:cubicBezTo>
+                  <a:pt x="2055" y="1265"/>
+                  <a:pt x="1916" y="1482"/>
+                  <a:pt x="1783" y="1707"/>
+                </a:cubicBezTo>
+                <a:lnTo>
+                  <a:pt x="1781" y="1707"/>
+                </a:lnTo>
+                <a:cubicBezTo>
+                  <a:pt x="1875" y="1480"/>
+                  <a:pt x="1926" y="1222"/>
+                  <a:pt x="1920" y="991"/>
+                </a:cubicBezTo>
+                <a:cubicBezTo>
+                  <a:pt x="1916" y="985"/>
+                  <a:pt x="1902" y="985"/>
+                  <a:pt x="1902" y="995"/>
+                </a:cubicBezTo>
+                <a:cubicBezTo>
+                  <a:pt x="1883" y="1253"/>
+                  <a:pt x="1793" y="1482"/>
+                  <a:pt x="1717" y="1726"/>
+                </a:cubicBezTo>
+                <a:cubicBezTo>
+                  <a:pt x="1668" y="1767"/>
+                  <a:pt x="1623" y="1805"/>
+                  <a:pt x="1578" y="1842"/>
+                </a:cubicBezTo>
+                <a:cubicBezTo>
+                  <a:pt x="1638" y="1609"/>
+                  <a:pt x="1634" y="1306"/>
+                  <a:pt x="1476" y="934"/>
+                </a:cubicBezTo>
+                <a:cubicBezTo>
+                  <a:pt x="1554" y="654"/>
+                  <a:pt x="1615" y="381"/>
+                  <a:pt x="1760" y="109"/>
+                </a:cubicBezTo>
+                <a:cubicBezTo>
+                  <a:pt x="1767" y="97"/>
+                  <a:pt x="1750" y="89"/>
+                  <a:pt x="1742" y="99"/>
+                </a:cubicBezTo>
+                <a:cubicBezTo>
+                  <a:pt x="1599" y="308"/>
+                  <a:pt x="1486" y="570"/>
+                  <a:pt x="1425" y="827"/>
+                </a:cubicBezTo>
+                <a:cubicBezTo>
+                  <a:pt x="1411" y="815"/>
+                  <a:pt x="1388" y="813"/>
+                  <a:pt x="1364" y="825"/>
+                </a:cubicBezTo>
+                <a:cubicBezTo>
+                  <a:pt x="1362" y="825"/>
+                  <a:pt x="1362" y="827"/>
+                  <a:pt x="1359" y="827"/>
+                </a:cubicBezTo>
+                <a:cubicBezTo>
+                  <a:pt x="1433" y="555"/>
+                  <a:pt x="1494" y="285"/>
+                  <a:pt x="1638" y="23"/>
+                </a:cubicBezTo>
+                <a:cubicBezTo>
+                  <a:pt x="1644" y="13"/>
+                  <a:pt x="1625" y="1"/>
+                  <a:pt x="1619" y="15"/>
+                </a:cubicBezTo>
+                <a:cubicBezTo>
+                  <a:pt x="1441" y="273"/>
+                  <a:pt x="1310" y="611"/>
+                  <a:pt x="1267" y="928"/>
+                </a:cubicBezTo>
+                <a:cubicBezTo>
+                  <a:pt x="1065" y="1161"/>
+                  <a:pt x="924" y="1370"/>
+                  <a:pt x="856" y="1572"/>
+                </a:cubicBezTo>
+                <a:cubicBezTo>
+                  <a:pt x="805" y="1509"/>
+                  <a:pt x="748" y="1443"/>
+                  <a:pt x="688" y="1378"/>
+                </a:cubicBezTo>
+                <a:lnTo>
+                  <a:pt x="688" y="1378"/>
+                </a:lnTo>
+                <a:cubicBezTo>
+                  <a:pt x="678" y="1145"/>
+                  <a:pt x="686" y="915"/>
+                  <a:pt x="789" y="682"/>
+                </a:cubicBezTo>
+                <a:cubicBezTo>
+                  <a:pt x="797" y="672"/>
+                  <a:pt x="780" y="664"/>
+                  <a:pt x="774" y="674"/>
+                </a:cubicBezTo>
+                <a:cubicBezTo>
+                  <a:pt x="672" y="866"/>
+                  <a:pt x="611" y="1126"/>
+                  <a:pt x="611" y="1372"/>
+                </a:cubicBezTo>
+                <a:cubicBezTo>
+                  <a:pt x="605" y="1378"/>
+                  <a:pt x="600" y="1386"/>
+                  <a:pt x="596" y="1394"/>
+                </a:cubicBezTo>
+                <a:lnTo>
+                  <a:pt x="582" y="1431"/>
+                </a:lnTo>
+                <a:cubicBezTo>
+                  <a:pt x="543" y="1214"/>
+                  <a:pt x="541" y="997"/>
+                  <a:pt x="643" y="768"/>
+                </a:cubicBezTo>
+                <a:cubicBezTo>
+                  <a:pt x="645" y="764"/>
+                  <a:pt x="635" y="758"/>
+                  <a:pt x="631" y="766"/>
+                </a:cubicBezTo>
+                <a:cubicBezTo>
+                  <a:pt x="504" y="995"/>
+                  <a:pt x="484" y="1286"/>
+                  <a:pt x="539" y="1544"/>
+                </a:cubicBezTo>
+                <a:cubicBezTo>
+                  <a:pt x="355" y="2065"/>
+                  <a:pt x="390" y="2452"/>
+                  <a:pt x="508" y="2728"/>
+                </a:cubicBezTo>
+                <a:cubicBezTo>
+                  <a:pt x="492" y="2716"/>
+                  <a:pt x="474" y="2706"/>
+                  <a:pt x="457" y="2693"/>
+                </a:cubicBezTo>
+                <a:cubicBezTo>
+                  <a:pt x="451" y="2687"/>
+                  <a:pt x="443" y="2685"/>
+                  <a:pt x="437" y="2683"/>
+                </a:cubicBezTo>
+                <a:cubicBezTo>
+                  <a:pt x="422" y="2677"/>
+                  <a:pt x="408" y="2679"/>
+                  <a:pt x="398" y="2685"/>
+                </a:cubicBezTo>
+                <a:cubicBezTo>
+                  <a:pt x="328" y="2474"/>
+                  <a:pt x="279" y="2260"/>
+                  <a:pt x="267" y="2024"/>
+                </a:cubicBezTo>
+                <a:cubicBezTo>
+                  <a:pt x="265" y="2016"/>
+                  <a:pt x="253" y="2016"/>
+                  <a:pt x="253" y="2024"/>
+                </a:cubicBezTo>
+                <a:cubicBezTo>
+                  <a:pt x="244" y="2247"/>
+                  <a:pt x="277" y="2526"/>
+                  <a:pt x="357" y="2777"/>
+                </a:cubicBezTo>
+                <a:cubicBezTo>
+                  <a:pt x="246" y="3352"/>
+                  <a:pt x="345" y="3741"/>
+                  <a:pt x="504" y="3999"/>
+                </a:cubicBezTo>
+                <a:lnTo>
+                  <a:pt x="351" y="3923"/>
+                </a:lnTo>
+                <a:cubicBezTo>
+                  <a:pt x="347" y="3921"/>
+                  <a:pt x="339" y="3921"/>
+                  <a:pt x="330" y="3917"/>
+                </a:cubicBezTo>
+                <a:lnTo>
+                  <a:pt x="326" y="3917"/>
+                </a:lnTo>
+                <a:cubicBezTo>
+                  <a:pt x="144" y="3686"/>
+                  <a:pt x="30" y="3393"/>
+                  <a:pt x="38" y="3084"/>
+                </a:cubicBezTo>
+                <a:cubicBezTo>
+                  <a:pt x="38" y="3068"/>
+                  <a:pt x="17" y="3068"/>
+                  <a:pt x="17" y="3082"/>
+                </a:cubicBezTo>
+                <a:cubicBezTo>
+                  <a:pt x="1" y="3289"/>
+                  <a:pt x="58" y="3487"/>
+                  <a:pt x="132" y="3671"/>
+                </a:cubicBezTo>
+                <a:cubicBezTo>
+                  <a:pt x="165" y="3757"/>
+                  <a:pt x="212" y="3860"/>
+                  <a:pt x="269" y="3945"/>
+                </a:cubicBezTo>
+                <a:cubicBezTo>
+                  <a:pt x="267" y="3952"/>
+                  <a:pt x="265" y="3958"/>
+                  <a:pt x="265" y="3964"/>
+                </a:cubicBezTo>
+                <a:cubicBezTo>
+                  <a:pt x="206" y="4436"/>
+                  <a:pt x="316" y="4745"/>
+                  <a:pt x="482" y="4952"/>
+                </a:cubicBezTo>
+                <a:cubicBezTo>
+                  <a:pt x="478" y="4950"/>
+                  <a:pt x="469" y="4950"/>
+                  <a:pt x="463" y="4950"/>
+                </a:cubicBezTo>
+                <a:cubicBezTo>
+                  <a:pt x="449" y="4950"/>
+                  <a:pt x="437" y="4958"/>
+                  <a:pt x="429" y="4968"/>
+                </a:cubicBezTo>
+                <a:cubicBezTo>
+                  <a:pt x="396" y="4927"/>
+                  <a:pt x="361" y="4885"/>
+                  <a:pt x="330" y="4835"/>
+                </a:cubicBezTo>
+                <a:cubicBezTo>
+                  <a:pt x="244" y="4686"/>
+                  <a:pt x="171" y="4529"/>
+                  <a:pt x="89" y="4375"/>
+                </a:cubicBezTo>
+                <a:cubicBezTo>
+                  <a:pt x="85" y="4365"/>
+                  <a:pt x="73" y="4375"/>
+                  <a:pt x="75" y="4383"/>
+                </a:cubicBezTo>
+                <a:cubicBezTo>
+                  <a:pt x="173" y="4588"/>
+                  <a:pt x="259" y="4854"/>
+                  <a:pt x="408" y="5048"/>
+                </a:cubicBezTo>
+                <a:cubicBezTo>
+                  <a:pt x="422" y="5588"/>
+                  <a:pt x="596" y="5887"/>
+                  <a:pt x="805" y="6051"/>
+                </a:cubicBezTo>
+                <a:cubicBezTo>
+                  <a:pt x="766" y="6045"/>
+                  <a:pt x="725" y="6043"/>
+                  <a:pt x="686" y="6040"/>
+                </a:cubicBezTo>
+                <a:cubicBezTo>
+                  <a:pt x="551" y="5899"/>
+                  <a:pt x="433" y="5736"/>
+                  <a:pt x="330" y="5570"/>
+                </a:cubicBezTo>
+                <a:cubicBezTo>
+                  <a:pt x="324" y="5560"/>
+                  <a:pt x="308" y="5570"/>
+                  <a:pt x="316" y="5580"/>
+                </a:cubicBezTo>
+                <a:cubicBezTo>
+                  <a:pt x="388" y="5709"/>
+                  <a:pt x="482" y="5883"/>
+                  <a:pt x="602" y="6036"/>
+                </a:cubicBezTo>
+                <a:lnTo>
+                  <a:pt x="600" y="6036"/>
+                </a:lnTo>
+                <a:cubicBezTo>
+                  <a:pt x="600" y="6036"/>
+                  <a:pt x="596" y="6036"/>
+                  <a:pt x="596" y="6040"/>
+                </a:cubicBezTo>
+                <a:cubicBezTo>
+                  <a:pt x="576" y="6024"/>
+                  <a:pt x="560" y="6006"/>
+                  <a:pt x="539" y="5985"/>
+                </a:cubicBezTo>
+                <a:cubicBezTo>
+                  <a:pt x="392" y="5840"/>
+                  <a:pt x="269" y="5666"/>
+                  <a:pt x="161" y="5492"/>
+                </a:cubicBezTo>
+                <a:cubicBezTo>
+                  <a:pt x="152" y="5482"/>
+                  <a:pt x="140" y="5494"/>
+                  <a:pt x="144" y="5502"/>
+                </a:cubicBezTo>
+                <a:cubicBezTo>
+                  <a:pt x="238" y="5676"/>
+                  <a:pt x="377" y="5924"/>
+                  <a:pt x="555" y="6100"/>
+                </a:cubicBezTo>
+                <a:lnTo>
+                  <a:pt x="555" y="6110"/>
+                </a:lnTo>
+                <a:cubicBezTo>
+                  <a:pt x="686" y="6701"/>
+                  <a:pt x="958" y="6961"/>
+                  <a:pt x="1226" y="7059"/>
+                </a:cubicBezTo>
+                <a:cubicBezTo>
+                  <a:pt x="1114" y="7063"/>
+                  <a:pt x="999" y="7072"/>
+                  <a:pt x="877" y="7084"/>
+                </a:cubicBezTo>
+                <a:cubicBezTo>
+                  <a:pt x="870" y="7084"/>
+                  <a:pt x="862" y="7086"/>
+                  <a:pt x="858" y="7088"/>
+                </a:cubicBezTo>
+                <a:cubicBezTo>
+                  <a:pt x="697" y="6963"/>
+                  <a:pt x="551" y="6797"/>
+                  <a:pt x="451" y="6605"/>
+                </a:cubicBezTo>
+                <a:cubicBezTo>
+                  <a:pt x="447" y="6597"/>
+                  <a:pt x="431" y="6607"/>
+                  <a:pt x="437" y="6617"/>
+                </a:cubicBezTo>
+                <a:cubicBezTo>
+                  <a:pt x="523" y="6818"/>
+                  <a:pt x="652" y="6973"/>
+                  <a:pt x="805" y="7111"/>
+                </a:cubicBezTo>
+                <a:cubicBezTo>
+                  <a:pt x="811" y="7117"/>
+                  <a:pt x="817" y="7125"/>
+                  <a:pt x="825" y="7129"/>
+                </a:cubicBezTo>
+                <a:cubicBezTo>
+                  <a:pt x="821" y="7139"/>
+                  <a:pt x="825" y="7151"/>
+                  <a:pt x="830" y="7162"/>
+                </a:cubicBezTo>
+                <a:cubicBezTo>
+                  <a:pt x="1374" y="8181"/>
+                  <a:pt x="2131" y="7976"/>
+                  <a:pt x="2397" y="7861"/>
+                </a:cubicBezTo>
+                <a:cubicBezTo>
+                  <a:pt x="2436" y="7927"/>
+                  <a:pt x="2477" y="7994"/>
+                  <a:pt x="2517" y="8060"/>
+                </a:cubicBezTo>
+                <a:cubicBezTo>
+                  <a:pt x="2474" y="8039"/>
+                  <a:pt x="2425" y="8023"/>
+                  <a:pt x="2376" y="8007"/>
+                </a:cubicBezTo>
+                <a:cubicBezTo>
+                  <a:pt x="2141" y="7941"/>
+                  <a:pt x="1859" y="7962"/>
+                  <a:pt x="1527" y="8025"/>
+                </a:cubicBezTo>
+                <a:cubicBezTo>
+                  <a:pt x="1523" y="8025"/>
+                  <a:pt x="1517" y="8027"/>
+                  <a:pt x="1515" y="8027"/>
+                </a:cubicBezTo>
+                <a:cubicBezTo>
+                  <a:pt x="1339" y="7915"/>
+                  <a:pt x="1173" y="7769"/>
+                  <a:pt x="1051" y="7604"/>
+                </a:cubicBezTo>
+                <a:cubicBezTo>
+                  <a:pt x="1042" y="7593"/>
+                  <a:pt x="1026" y="7599"/>
+                  <a:pt x="1032" y="7610"/>
+                </a:cubicBezTo>
+                <a:cubicBezTo>
+                  <a:pt x="1153" y="7794"/>
+                  <a:pt x="1306" y="7937"/>
+                  <a:pt x="1486" y="8060"/>
+                </a:cubicBezTo>
+                <a:cubicBezTo>
+                  <a:pt x="1482" y="8074"/>
+                  <a:pt x="1484" y="8088"/>
+                  <a:pt x="1490" y="8101"/>
+                </a:cubicBezTo>
+                <a:cubicBezTo>
+                  <a:pt x="1501" y="8119"/>
+                  <a:pt x="1507" y="8136"/>
+                  <a:pt x="1517" y="8152"/>
+                </a:cubicBezTo>
+                <a:cubicBezTo>
+                  <a:pt x="1513" y="8150"/>
+                  <a:pt x="1507" y="8148"/>
+                  <a:pt x="1501" y="8142"/>
+                </a:cubicBezTo>
+                <a:cubicBezTo>
+                  <a:pt x="1306" y="8027"/>
+                  <a:pt x="1124" y="7872"/>
+                  <a:pt x="991" y="7690"/>
+                </a:cubicBezTo>
+                <a:cubicBezTo>
+                  <a:pt x="983" y="7679"/>
+                  <a:pt x="969" y="7687"/>
+                  <a:pt x="973" y="7698"/>
+                </a:cubicBezTo>
+                <a:cubicBezTo>
+                  <a:pt x="1093" y="7884"/>
+                  <a:pt x="1249" y="8027"/>
+                  <a:pt x="1433" y="8152"/>
+                </a:cubicBezTo>
+                <a:cubicBezTo>
+                  <a:pt x="1474" y="8181"/>
+                  <a:pt x="1521" y="8209"/>
+                  <a:pt x="1566" y="8238"/>
+                </a:cubicBezTo>
+                <a:cubicBezTo>
+                  <a:pt x="2106" y="9107"/>
+                  <a:pt x="2790" y="8684"/>
+                  <a:pt x="2896" y="8608"/>
+                </a:cubicBezTo>
+                <a:cubicBezTo>
+                  <a:pt x="2943" y="8669"/>
+                  <a:pt x="2990" y="8731"/>
+                  <a:pt x="3041" y="8792"/>
+                </a:cubicBezTo>
+                <a:cubicBezTo>
+                  <a:pt x="3008" y="8784"/>
+                  <a:pt x="2976" y="8776"/>
+                  <a:pt x="2939" y="8772"/>
+                </a:cubicBezTo>
+                <a:cubicBezTo>
+                  <a:pt x="2693" y="8739"/>
+                  <a:pt x="2411" y="8802"/>
+                  <a:pt x="2090" y="8909"/>
+                </a:cubicBezTo>
+                <a:cubicBezTo>
+                  <a:pt x="2086" y="8913"/>
+                  <a:pt x="2084" y="8913"/>
+                  <a:pt x="2078" y="8915"/>
+                </a:cubicBezTo>
+                <a:cubicBezTo>
+                  <a:pt x="2037" y="8895"/>
+                  <a:pt x="1996" y="8874"/>
+                  <a:pt x="1955" y="8852"/>
+                </a:cubicBezTo>
+                <a:cubicBezTo>
+                  <a:pt x="1760" y="8735"/>
+                  <a:pt x="1578" y="8579"/>
+                  <a:pt x="1445" y="8397"/>
+                </a:cubicBezTo>
+                <a:cubicBezTo>
+                  <a:pt x="1439" y="8387"/>
+                  <a:pt x="1421" y="8397"/>
+                  <a:pt x="1429" y="8406"/>
+                </a:cubicBezTo>
+                <a:cubicBezTo>
+                  <a:pt x="1548" y="8592"/>
+                  <a:pt x="1705" y="8735"/>
+                  <a:pt x="1889" y="8862"/>
+                </a:cubicBezTo>
+                <a:cubicBezTo>
+                  <a:pt x="1941" y="8895"/>
+                  <a:pt x="1994" y="8929"/>
+                  <a:pt x="2053" y="8964"/>
+                </a:cubicBezTo>
+                <a:cubicBezTo>
+                  <a:pt x="2053" y="8974"/>
+                  <a:pt x="2057" y="8985"/>
+                  <a:pt x="2063" y="8991"/>
+                </a:cubicBezTo>
+                <a:cubicBezTo>
+                  <a:pt x="2088" y="9025"/>
+                  <a:pt x="2110" y="9056"/>
+                  <a:pt x="2137" y="9087"/>
+                </a:cubicBezTo>
+                <a:cubicBezTo>
+                  <a:pt x="2118" y="9079"/>
+                  <a:pt x="2104" y="9071"/>
+                  <a:pt x="2086" y="9060"/>
+                </a:cubicBezTo>
+                <a:cubicBezTo>
+                  <a:pt x="1885" y="8954"/>
+                  <a:pt x="1699" y="8805"/>
+                  <a:pt x="1558" y="8629"/>
+                </a:cubicBezTo>
+                <a:cubicBezTo>
+                  <a:pt x="1552" y="8618"/>
+                  <a:pt x="1535" y="8627"/>
+                  <a:pt x="1544" y="8637"/>
+                </a:cubicBezTo>
+                <a:cubicBezTo>
+                  <a:pt x="1670" y="8817"/>
+                  <a:pt x="1832" y="8954"/>
+                  <a:pt x="2022" y="9073"/>
+                </a:cubicBezTo>
+                <a:cubicBezTo>
+                  <a:pt x="2084" y="9113"/>
+                  <a:pt x="2155" y="9154"/>
+                  <a:pt x="2231" y="9191"/>
+                </a:cubicBezTo>
+                <a:cubicBezTo>
+                  <a:pt x="2816" y="9797"/>
+                  <a:pt x="3358" y="9441"/>
+                  <a:pt x="3516" y="9314"/>
+                </a:cubicBezTo>
+                <a:cubicBezTo>
+                  <a:pt x="3714" y="9510"/>
+                  <a:pt x="3929" y="9703"/>
+                  <a:pt x="4162" y="9885"/>
+                </a:cubicBezTo>
+                <a:cubicBezTo>
+                  <a:pt x="4185" y="9901"/>
+                  <a:pt x="4222" y="9897"/>
+                  <a:pt x="4242" y="9870"/>
+                </a:cubicBezTo>
+                <a:cubicBezTo>
+                  <a:pt x="4263" y="9846"/>
+                  <a:pt x="4267" y="9817"/>
+                  <a:pt x="4244" y="9799"/>
+                </a:cubicBezTo>
+                <a:close/>
+                <a:moveTo>
+                  <a:pt x="1210" y="4531"/>
+                </a:moveTo>
+                <a:cubicBezTo>
+                  <a:pt x="1204" y="4524"/>
+                  <a:pt x="1198" y="4514"/>
+                  <a:pt x="1190" y="4506"/>
+                </a:cubicBezTo>
+                <a:cubicBezTo>
+                  <a:pt x="1204" y="4508"/>
+                  <a:pt x="1214" y="4510"/>
+                  <a:pt x="1218" y="4514"/>
+                </a:cubicBezTo>
+                <a:cubicBezTo>
+                  <a:pt x="1216" y="4518"/>
+                  <a:pt x="1214" y="4526"/>
+                  <a:pt x="1210" y="4531"/>
+                </a:cubicBezTo>
+                <a:close/>
+                <a:moveTo>
+                  <a:pt x="2161" y="7145"/>
+                </a:moveTo>
+                <a:lnTo>
+                  <a:pt x="2161" y="7160"/>
+                </a:lnTo>
+                <a:cubicBezTo>
+                  <a:pt x="2159" y="7158"/>
+                  <a:pt x="2159" y="7151"/>
+                  <a:pt x="2157" y="7149"/>
+                </a:cubicBezTo>
+                <a:cubicBezTo>
+                  <a:pt x="2159" y="7147"/>
+                  <a:pt x="2161" y="7147"/>
+                  <a:pt x="2161" y="7145"/>
+                </a:cubicBezTo>
+                <a:close/>
+                <a:moveTo>
+                  <a:pt x="1883" y="7076"/>
+                </a:moveTo>
+                <a:cubicBezTo>
+                  <a:pt x="1914" y="7115"/>
+                  <a:pt x="1947" y="7149"/>
+                  <a:pt x="1986" y="7188"/>
+                </a:cubicBezTo>
+                <a:cubicBezTo>
+                  <a:pt x="1953" y="7174"/>
+                  <a:pt x="1916" y="7160"/>
+                  <a:pt x="1879" y="7147"/>
+                </a:cubicBezTo>
+                <a:cubicBezTo>
+                  <a:pt x="1834" y="7133"/>
+                  <a:pt x="1789" y="7119"/>
+                  <a:pt x="1740" y="7108"/>
+                </a:cubicBezTo>
+                <a:cubicBezTo>
+                  <a:pt x="1799" y="7098"/>
+                  <a:pt x="1848" y="7086"/>
+                  <a:pt x="1883" y="7076"/>
+                </a:cubicBezTo>
+                <a:close/>
+                <a:moveTo>
+                  <a:pt x="2526" y="7775"/>
+                </a:moveTo>
+                <a:cubicBezTo>
+                  <a:pt x="2548" y="7755"/>
+                  <a:pt x="2601" y="7700"/>
+                  <a:pt x="2667" y="7618"/>
+                </a:cubicBezTo>
+                <a:cubicBezTo>
+                  <a:pt x="2642" y="7698"/>
+                  <a:pt x="2628" y="7773"/>
+                  <a:pt x="2618" y="7849"/>
+                </a:cubicBezTo>
+                <a:cubicBezTo>
+                  <a:pt x="2612" y="7896"/>
+                  <a:pt x="2610" y="7945"/>
+                  <a:pt x="2612" y="7994"/>
+                </a:cubicBezTo>
+                <a:cubicBezTo>
+                  <a:pt x="2575" y="7935"/>
+                  <a:pt x="2538" y="7874"/>
+                  <a:pt x="2503" y="7814"/>
+                </a:cubicBezTo>
+                <a:cubicBezTo>
+                  <a:pt x="2517" y="7804"/>
+                  <a:pt x="2526" y="7790"/>
+                  <a:pt x="2526" y="7775"/>
+                </a:cubicBezTo>
+                <a:close/>
+                <a:moveTo>
+                  <a:pt x="3180" y="8342"/>
+                </a:moveTo>
+                <a:cubicBezTo>
+                  <a:pt x="3168" y="8424"/>
+                  <a:pt x="3162" y="8506"/>
+                  <a:pt x="3164" y="8582"/>
+                </a:cubicBezTo>
+                <a:cubicBezTo>
+                  <a:pt x="3168" y="8653"/>
+                  <a:pt x="3178" y="8725"/>
+                  <a:pt x="3195" y="8792"/>
+                </a:cubicBezTo>
+                <a:cubicBezTo>
+                  <a:pt x="3129" y="8712"/>
+                  <a:pt x="3062" y="8631"/>
+                  <a:pt x="3000" y="8549"/>
+                </a:cubicBezTo>
+                <a:cubicBezTo>
+                  <a:pt x="3047" y="8506"/>
+                  <a:pt x="3117" y="8436"/>
+                  <a:pt x="3180" y="8342"/>
+                </a:cubicBezTo>
+                <a:close/>
+              </a:path>
+            </a:pathLst>
+          </a:custGeom>
+          <a:solidFill>
+            <a:schemeClr val="dk1"/>
+          </a:solidFill>
+          <a:ln>
+            <a:noFill/>
+          </a:ln>
+        </p:spPr>
+        <p:txBody>
+          <a:bodyPr spcFirstLastPara="1" wrap="square" lIns="91425" tIns="91425" rIns="91425" bIns="91425" anchor="ctr" anchorCtr="0">
+            <a:noAutofit/>
+          </a:bodyPr>
+          <a:lstStyle/>
+          <a:p>
+            <a:pPr marL="0" lvl="0" indent="0" algn="l" rtl="0">
+              <a:spcBef>
+                <a:spcPts val="0"/>
+              </a:spcBef>
+              <a:spcAft>
+                <a:spcPts val="0"/>
+              </a:spcAft>
+              <a:buNone/>
+            </a:pPr>
+            <a:endParaRPr/>
+          </a:p>
+        </p:txBody>
+      </p:sp>
+    </p:spTree>
+    <p:extLst>
+      <p:ext uri="{BB962C8B-B14F-4D97-AF65-F5344CB8AC3E}">
+        <p14:creationId xmlns:p14="http://schemas.microsoft.com/office/powerpoint/2010/main" val="2718970267"/>
+      </p:ext>
+    </p:extLst>
+  </p:cSld>
+  <p:clrMapOvr>
+    <a:masterClrMapping/>
+  </p:clrMapOvr>
+</p:sld>
+</file>
+
+<file path=ppt/slides/slide15.xml><?xml version="1.0" encoding="utf-8"?>
+<p:sld xmlns:a="http://schemas.openxmlformats.org/drawingml/2006/main" xmlns:r="http://schemas.openxmlformats.org/officeDocument/2006/relationships" xmlns:p="http://schemas.openxmlformats.org/presentationml/2006/main">
+  <p:cSld>
+    <p:spTree>
+      <p:nvGrpSpPr>
+        <p:cNvPr id="1" name="Shape 602">
+          <a:extLst>
+            <a:ext uri="{FF2B5EF4-FFF2-40B4-BE49-F238E27FC236}">
+              <a16:creationId xmlns:a16="http://schemas.microsoft.com/office/drawing/2014/main" id="{B3700B5A-025A-6E73-E927-39BE494F7FB6}"/>
+            </a:ext>
+          </a:extLst>
+        </p:cNvPr>
+        <p:cNvGrpSpPr/>
+        <p:nvPr/>
+      </p:nvGrpSpPr>
+      <p:grpSpPr>
+        <a:xfrm>
+          <a:off x="0" y="0"/>
+          <a:ext cx="0" cy="0"/>
+          <a:chOff x="0" y="0"/>
+          <a:chExt cx="0" cy="0"/>
+        </a:xfrm>
+      </p:grpSpPr>
+      <p:pic>
+        <p:nvPicPr>
+          <p:cNvPr id="605" name="Google Shape;605;p43">
+            <a:extLst>
+              <a:ext uri="{FF2B5EF4-FFF2-40B4-BE49-F238E27FC236}">
+                <a16:creationId xmlns:a16="http://schemas.microsoft.com/office/drawing/2014/main" id="{33D62EF9-0878-1632-30A6-7D259FC22128}"/>
+              </a:ext>
+            </a:extLst>
+          </p:cNvPr>
+          <p:cNvPicPr preferRelativeResize="0"/>
+          <p:nvPr/>
+        </p:nvPicPr>
+        <p:blipFill>
+          <a:blip r:embed="rId3">
+            <a:alphaModFix/>
+          </a:blip>
+          <a:stretch>
+            <a:fillRect/>
+          </a:stretch>
+        </p:blipFill>
+        <p:spPr>
+          <a:xfrm>
+            <a:off x="-58454" y="3464362"/>
+            <a:ext cx="6773509" cy="1524025"/>
+          </a:xfrm>
+          <a:prstGeom prst="rect">
+            <a:avLst/>
+          </a:prstGeom>
+          <a:noFill/>
+          <a:ln>
+            <a:noFill/>
+          </a:ln>
+        </p:spPr>
+      </p:pic>
+      <p:pic>
+        <p:nvPicPr>
+          <p:cNvPr id="606" name="Google Shape;606;p43">
+            <a:extLst>
+              <a:ext uri="{FF2B5EF4-FFF2-40B4-BE49-F238E27FC236}">
+                <a16:creationId xmlns:a16="http://schemas.microsoft.com/office/drawing/2014/main" id="{E3B6FC67-E59C-5EB7-F29C-FAB1CC62A804}"/>
+              </a:ext>
+            </a:extLst>
+          </p:cNvPr>
+          <p:cNvPicPr preferRelativeResize="0"/>
+          <p:nvPr/>
+        </p:nvPicPr>
+        <p:blipFill>
+          <a:blip r:embed="rId4">
+            <a:alphaModFix/>
+          </a:blip>
+          <a:stretch>
+            <a:fillRect/>
+          </a:stretch>
+        </p:blipFill>
+        <p:spPr>
+          <a:xfrm>
+            <a:off x="2555950" y="3559650"/>
+            <a:ext cx="910205" cy="699499"/>
+          </a:xfrm>
+          <a:prstGeom prst="rect">
+            <a:avLst/>
+          </a:prstGeom>
+          <a:noFill/>
+          <a:ln>
+            <a:noFill/>
+          </a:ln>
+        </p:spPr>
+      </p:pic>
+      <p:pic>
+        <p:nvPicPr>
+          <p:cNvPr id="607" name="Google Shape;607;p43">
+            <a:extLst>
+              <a:ext uri="{FF2B5EF4-FFF2-40B4-BE49-F238E27FC236}">
+                <a16:creationId xmlns:a16="http://schemas.microsoft.com/office/drawing/2014/main" id="{5098AF0D-C768-DAAD-2787-1C3A5887A963}"/>
+              </a:ext>
+            </a:extLst>
+          </p:cNvPr>
+          <p:cNvPicPr preferRelativeResize="0"/>
+          <p:nvPr/>
+        </p:nvPicPr>
+        <p:blipFill>
+          <a:blip r:embed="rId5">
+            <a:alphaModFix/>
+          </a:blip>
+          <a:stretch>
+            <a:fillRect/>
+          </a:stretch>
+        </p:blipFill>
+        <p:spPr>
+          <a:xfrm>
+            <a:off x="100757" y="3359715"/>
+            <a:ext cx="1532296" cy="1152076"/>
+          </a:xfrm>
+          <a:prstGeom prst="rect">
+            <a:avLst/>
+          </a:prstGeom>
+          <a:noFill/>
+          <a:ln>
+            <a:noFill/>
+          </a:ln>
+        </p:spPr>
+      </p:pic>
+      <p:pic>
+        <p:nvPicPr>
+          <p:cNvPr id="608" name="Google Shape;608;p43">
+            <a:extLst>
+              <a:ext uri="{FF2B5EF4-FFF2-40B4-BE49-F238E27FC236}">
+                <a16:creationId xmlns:a16="http://schemas.microsoft.com/office/drawing/2014/main" id="{EC15FEA8-4AFD-5248-4F92-B1BB9A25381A}"/>
+              </a:ext>
+            </a:extLst>
+          </p:cNvPr>
+          <p:cNvPicPr preferRelativeResize="0"/>
+          <p:nvPr/>
+        </p:nvPicPr>
+        <p:blipFill>
+          <a:blip r:embed="rId6">
+            <a:alphaModFix/>
+          </a:blip>
+          <a:stretch>
+            <a:fillRect/>
+          </a:stretch>
+        </p:blipFill>
+        <p:spPr>
+          <a:xfrm>
+            <a:off x="2452622" y="4071046"/>
+            <a:ext cx="6773501" cy="1524023"/>
+          </a:xfrm>
+          <a:prstGeom prst="rect">
+            <a:avLst/>
+          </a:prstGeom>
+          <a:noFill/>
+          <a:ln>
+            <a:noFill/>
+          </a:ln>
+        </p:spPr>
+      </p:pic>
+      <p:pic>
+        <p:nvPicPr>
+          <p:cNvPr id="609" name="Google Shape;609;p43">
+            <a:extLst>
+              <a:ext uri="{FF2B5EF4-FFF2-40B4-BE49-F238E27FC236}">
+                <a16:creationId xmlns:a16="http://schemas.microsoft.com/office/drawing/2014/main" id="{47A12408-ED7D-CD50-0272-D4DFB1A2CB0D}"/>
+              </a:ext>
+            </a:extLst>
+          </p:cNvPr>
+          <p:cNvPicPr preferRelativeResize="0"/>
+          <p:nvPr/>
+        </p:nvPicPr>
+        <p:blipFill>
+          <a:blip r:embed="rId7">
+            <a:alphaModFix/>
+          </a:blip>
+          <a:stretch>
+            <a:fillRect/>
+          </a:stretch>
+        </p:blipFill>
+        <p:spPr>
+          <a:xfrm>
+            <a:off x="5624057" y="3559639"/>
+            <a:ext cx="1859474" cy="979674"/>
+          </a:xfrm>
+          <a:prstGeom prst="rect">
+            <a:avLst/>
+          </a:prstGeom>
+          <a:noFill/>
+          <a:ln>
+            <a:noFill/>
+          </a:ln>
+        </p:spPr>
+      </p:pic>
+      <p:pic>
+        <p:nvPicPr>
+          <p:cNvPr id="610" name="Google Shape;610;p43">
+            <a:extLst>
+              <a:ext uri="{FF2B5EF4-FFF2-40B4-BE49-F238E27FC236}">
+                <a16:creationId xmlns:a16="http://schemas.microsoft.com/office/drawing/2014/main" id="{EA128192-AE31-8C63-9727-7702F979FC57}"/>
+              </a:ext>
+            </a:extLst>
+          </p:cNvPr>
+          <p:cNvPicPr preferRelativeResize="0"/>
+          <p:nvPr/>
+        </p:nvPicPr>
+        <p:blipFill>
+          <a:blip r:embed="rId8">
+            <a:alphaModFix/>
+          </a:blip>
+          <a:stretch>
+            <a:fillRect/>
+          </a:stretch>
+        </p:blipFill>
+        <p:spPr>
+          <a:xfrm>
+            <a:off x="7116552" y="3917431"/>
+            <a:ext cx="2905600" cy="699511"/>
+          </a:xfrm>
+          <a:prstGeom prst="rect">
+            <a:avLst/>
+          </a:prstGeom>
+          <a:noFill/>
+          <a:ln>
+            <a:noFill/>
+          </a:ln>
+        </p:spPr>
+      </p:pic>
+      <p:pic>
+        <p:nvPicPr>
+          <p:cNvPr id="612" name="Google Shape;612;p43">
+            <a:extLst>
+              <a:ext uri="{FF2B5EF4-FFF2-40B4-BE49-F238E27FC236}">
+                <a16:creationId xmlns:a16="http://schemas.microsoft.com/office/drawing/2014/main" id="{FC5B7CCD-0358-2657-D5C7-3724BB40CB48}"/>
+              </a:ext>
+            </a:extLst>
+          </p:cNvPr>
+          <p:cNvPicPr preferRelativeResize="0"/>
+          <p:nvPr/>
+        </p:nvPicPr>
+        <p:blipFill>
+          <a:blip r:embed="rId9">
+            <a:alphaModFix/>
+          </a:blip>
+          <a:stretch>
+            <a:fillRect/>
+          </a:stretch>
+        </p:blipFill>
+        <p:spPr>
+          <a:xfrm>
+            <a:off x="7443904" y="3368485"/>
+            <a:ext cx="1902965" cy="458100"/>
+          </a:xfrm>
+          <a:prstGeom prst="rect">
+            <a:avLst/>
+          </a:prstGeom>
+          <a:noFill/>
+          <a:ln>
+            <a:noFill/>
+          </a:ln>
+        </p:spPr>
+      </p:pic>
+      <p:sp>
+        <p:nvSpPr>
+          <p:cNvPr id="613" name="Google Shape;613;p43">
+            <a:extLst>
+              <a:ext uri="{FF2B5EF4-FFF2-40B4-BE49-F238E27FC236}">
+                <a16:creationId xmlns:a16="http://schemas.microsoft.com/office/drawing/2014/main" id="{2B85319D-B8F7-C280-F85D-CD28FADA04F5}"/>
+              </a:ext>
+            </a:extLst>
+          </p:cNvPr>
+          <p:cNvSpPr/>
+          <p:nvPr/>
+        </p:nvSpPr>
+        <p:spPr>
+          <a:xfrm>
+            <a:off x="0" y="4584375"/>
+            <a:ext cx="9144100" cy="572711"/>
+          </a:xfrm>
+          <a:custGeom>
+            <a:avLst/>
+            <a:gdLst/>
+            <a:ahLst/>
+            <a:cxnLst/>
+            <a:rect l="l" t="t" r="r" b="b"/>
+            <a:pathLst>
+              <a:path w="120021" h="12052" extrusionOk="0">
+                <a:moveTo>
+                  <a:pt x="0" y="4058"/>
+                </a:moveTo>
+                <a:cubicBezTo>
+                  <a:pt x="4119" y="756"/>
+                  <a:pt x="10592" y="1"/>
+                  <a:pt x="16024" y="4610"/>
+                </a:cubicBezTo>
+                <a:cubicBezTo>
+                  <a:pt x="20288" y="8229"/>
+                  <a:pt x="25095" y="8710"/>
+                  <a:pt x="30118" y="8076"/>
+                </a:cubicBezTo>
+                <a:cubicBezTo>
+                  <a:pt x="60461" y="4250"/>
+                  <a:pt x="56265" y="2278"/>
+                  <a:pt x="88006" y="7789"/>
+                </a:cubicBezTo>
+                <a:cubicBezTo>
+                  <a:pt x="93710" y="8780"/>
+                  <a:pt x="99197" y="8686"/>
+                  <a:pt x="103997" y="4610"/>
+                </a:cubicBezTo>
+                <a:cubicBezTo>
+                  <a:pt x="109428" y="1"/>
+                  <a:pt x="115898" y="758"/>
+                  <a:pt x="120020" y="4058"/>
+                </a:cubicBezTo>
+                <a:lnTo>
+                  <a:pt x="120020" y="12051"/>
+                </a:lnTo>
+                <a:lnTo>
+                  <a:pt x="4" y="12051"/>
+                </a:lnTo>
+                <a:lnTo>
+                  <a:pt x="4" y="4058"/>
+                </a:lnTo>
+                <a:close/>
+              </a:path>
+            </a:pathLst>
+          </a:custGeom>
+          <a:solidFill>
+            <a:srgbClr val="47922C"/>
+          </a:solidFill>
+          <a:ln>
+            <a:noFill/>
+          </a:ln>
+        </p:spPr>
+        <p:txBody>
+          <a:bodyPr spcFirstLastPara="1" wrap="square" lIns="91425" tIns="91425" rIns="91425" bIns="91425" anchor="ctr" anchorCtr="0">
+            <a:noAutofit/>
+          </a:bodyPr>
+          <a:lstStyle/>
+          <a:p>
+            <a:pPr marL="0" lvl="0" indent="0" algn="l" rtl="0">
+              <a:spcBef>
+                <a:spcPts val="0"/>
+              </a:spcBef>
+              <a:spcAft>
+                <a:spcPts val="0"/>
+              </a:spcAft>
+              <a:buNone/>
+            </a:pPr>
+            <a:endParaRPr/>
+          </a:p>
+        </p:txBody>
+      </p:sp>
+      <p:sp>
+        <p:nvSpPr>
+          <p:cNvPr id="614" name="Google Shape;614;p43">
+            <a:extLst>
+              <a:ext uri="{FF2B5EF4-FFF2-40B4-BE49-F238E27FC236}">
+                <a16:creationId xmlns:a16="http://schemas.microsoft.com/office/drawing/2014/main" id="{54EFEC17-B1E6-0379-4963-D0E6D8461992}"/>
+              </a:ext>
+            </a:extLst>
+          </p:cNvPr>
+          <p:cNvSpPr/>
+          <p:nvPr/>
+        </p:nvSpPr>
+        <p:spPr>
+          <a:xfrm rot="5400000">
+            <a:off x="6136032" y="-1514776"/>
+            <a:ext cx="1498366" cy="4517568"/>
+          </a:xfrm>
+          <a:custGeom>
+            <a:avLst/>
+            <a:gdLst/>
+            <a:ahLst/>
+            <a:cxnLst/>
+            <a:rect l="l" t="t" r="r" b="b"/>
+            <a:pathLst>
+              <a:path w="24830" h="46409" extrusionOk="0">
+                <a:moveTo>
+                  <a:pt x="23815" y="0"/>
+                </a:moveTo>
+                <a:lnTo>
+                  <a:pt x="0" y="0"/>
+                </a:lnTo>
+                <a:lnTo>
+                  <a:pt x="0" y="46408"/>
+                </a:lnTo>
+                <a:cubicBezTo>
+                  <a:pt x="8919" y="42992"/>
+                  <a:pt x="9966" y="38648"/>
+                  <a:pt x="7423" y="29634"/>
+                </a:cubicBezTo>
+                <a:cubicBezTo>
+                  <a:pt x="3384" y="15320"/>
+                  <a:pt x="13174" y="18559"/>
+                  <a:pt x="18602" y="14529"/>
+                </a:cubicBezTo>
+                <a:cubicBezTo>
+                  <a:pt x="24030" y="10496"/>
+                  <a:pt x="24830" y="4935"/>
+                  <a:pt x="23815" y="0"/>
+                </a:cubicBezTo>
+                <a:close/>
+              </a:path>
+            </a:pathLst>
+          </a:custGeom>
+          <a:solidFill>
+            <a:srgbClr val="47922C"/>
+          </a:solidFill>
+          <a:ln>
+            <a:noFill/>
+          </a:ln>
+        </p:spPr>
+        <p:txBody>
+          <a:bodyPr spcFirstLastPara="1" wrap="square" lIns="91425" tIns="91425" rIns="91425" bIns="91425" anchor="ctr" anchorCtr="0">
+            <a:noAutofit/>
+          </a:bodyPr>
+          <a:lstStyle/>
+          <a:p>
+            <a:pPr marL="0" lvl="0" indent="0" algn="l" rtl="0">
+              <a:spcBef>
+                <a:spcPts val="0"/>
+              </a:spcBef>
+              <a:spcAft>
+                <a:spcPts val="0"/>
+              </a:spcAft>
+              <a:buNone/>
+            </a:pPr>
+            <a:endParaRPr/>
+          </a:p>
+        </p:txBody>
+      </p:sp>
+      <p:graphicFrame>
+        <p:nvGraphicFramePr>
+          <p:cNvPr id="3" name="Table 2">
+            <a:extLst>
+              <a:ext uri="{FF2B5EF4-FFF2-40B4-BE49-F238E27FC236}">
+                <a16:creationId xmlns:a16="http://schemas.microsoft.com/office/drawing/2014/main" id="{96DCDBB9-3406-4B48-086A-6B7AFE362F6F}"/>
+              </a:ext>
+            </a:extLst>
+          </p:cNvPr>
+          <p:cNvGraphicFramePr>
+            <a:graphicFrameLocks noGrp="1"/>
+          </p:cNvGraphicFramePr>
+          <p:nvPr>
+            <p:extLst>
+              <p:ext uri="{D42A27DB-BD31-4B8C-83A1-F6EECF244321}">
+                <p14:modId xmlns:p14="http://schemas.microsoft.com/office/powerpoint/2010/main" val="3781278116"/>
+              </p:ext>
+            </p:extLst>
+          </p:nvPr>
+        </p:nvGraphicFramePr>
+        <p:xfrm>
+          <a:off x="714375" y="2251075"/>
+          <a:ext cx="7715250" cy="1219200"/>
+        </p:xfrm>
+        <a:graphic>
+          <a:graphicData uri="http://schemas.openxmlformats.org/drawingml/2006/table">
+            <a:tbl>
+              <a:tblPr/>
+              <a:tblGrid>
+                <a:gridCol w="3857625">
+                  <a:extLst>
+                    <a:ext uri="{9D8B030D-6E8A-4147-A177-3AD203B41FA5}">
+                      <a16:colId xmlns:a16="http://schemas.microsoft.com/office/drawing/2014/main" val="1335481100"/>
+                    </a:ext>
+                  </a:extLst>
+                </a:gridCol>
+                <a:gridCol w="3857625">
+                  <a:extLst>
+                    <a:ext uri="{9D8B030D-6E8A-4147-A177-3AD203B41FA5}">
+                      <a16:colId xmlns:a16="http://schemas.microsoft.com/office/drawing/2014/main" val="906582851"/>
+                    </a:ext>
+                  </a:extLst>
+                </a:gridCol>
+              </a:tblGrid>
+              <a:tr h="0">
+                <a:tc>
+                  <a:txBody>
+                    <a:bodyPr/>
+                    <a:lstStyle/>
+                    <a:p>
+                      <a:pPr>
+                        <a:buNone/>
+                      </a:pPr>
+                      <a:endParaRPr lang="fr-FR" dirty="0"/>
+                    </a:p>
+                  </a:txBody>
+                  <a:tcPr anchor="ctr">
+                    <a:lnL>
+                      <a:noFill/>
+                    </a:lnL>
+                    <a:lnR>
+                      <a:noFill/>
+                    </a:lnR>
+                    <a:lnT>
+                      <a:noFill/>
+                    </a:lnT>
+                    <a:lnB>
+                      <a:noFill/>
+                    </a:lnB>
+                    <a:noFill/>
+                  </a:tcPr>
+                </a:tc>
+                <a:tc>
+                  <a:txBody>
+                    <a:bodyPr/>
+                    <a:lstStyle/>
+                    <a:p>
+                      <a:pPr>
+                        <a:buNone/>
+                      </a:pPr>
+                      <a:endParaRPr lang="fr-FR"/>
+                    </a:p>
+                  </a:txBody>
+                  <a:tcPr anchor="ctr">
+                    <a:lnL>
+                      <a:noFill/>
+                    </a:lnL>
+                    <a:lnR>
+                      <a:noFill/>
+                    </a:lnR>
+                    <a:lnT>
+                      <a:noFill/>
+                    </a:lnT>
+                    <a:lnB>
+                      <a:noFill/>
+                    </a:lnB>
+                    <a:noFill/>
+                  </a:tcPr>
+                </a:tc>
+                <a:extLst>
+                  <a:ext uri="{0D108BD9-81ED-4DB2-BD59-A6C34878D82A}">
+                    <a16:rowId xmlns:a16="http://schemas.microsoft.com/office/drawing/2014/main" val="164321612"/>
+                  </a:ext>
+                </a:extLst>
+              </a:tr>
+              <a:tr h="0">
+                <a:tc>
+                  <a:txBody>
+                    <a:bodyPr/>
+                    <a:lstStyle/>
+                    <a:p>
+                      <a:pPr>
+                        <a:buNone/>
+                      </a:pPr>
+                      <a:endParaRPr lang="fr-FR"/>
+                    </a:p>
+                  </a:txBody>
+                  <a:tcPr anchor="ctr">
+                    <a:lnL>
+                      <a:noFill/>
+                    </a:lnL>
+                    <a:lnR>
+                      <a:noFill/>
+                    </a:lnR>
+                    <a:lnT>
+                      <a:noFill/>
+                    </a:lnT>
+                    <a:lnB>
+                      <a:noFill/>
+                    </a:lnB>
+                    <a:noFill/>
+                  </a:tcPr>
+                </a:tc>
+                <a:tc>
+                  <a:txBody>
+                    <a:bodyPr/>
+                    <a:lstStyle/>
+                    <a:p>
+                      <a:pPr>
+                        <a:buNone/>
+                      </a:pPr>
+                      <a:endParaRPr lang="fr-FR"/>
+                    </a:p>
+                  </a:txBody>
+                  <a:tcPr anchor="ctr">
+                    <a:lnL>
+                      <a:noFill/>
+                    </a:lnL>
+                    <a:lnR>
+                      <a:noFill/>
+                    </a:lnR>
+                    <a:lnT>
+                      <a:noFill/>
+                    </a:lnT>
+                    <a:lnB>
+                      <a:noFill/>
+                    </a:lnB>
+                    <a:noFill/>
+                  </a:tcPr>
+                </a:tc>
+                <a:extLst>
+                  <a:ext uri="{0D108BD9-81ED-4DB2-BD59-A6C34878D82A}">
+                    <a16:rowId xmlns:a16="http://schemas.microsoft.com/office/drawing/2014/main" val="3536524024"/>
+                  </a:ext>
+                </a:extLst>
+              </a:tr>
+              <a:tr h="0">
+                <a:tc>
+                  <a:txBody>
+                    <a:bodyPr/>
+                    <a:lstStyle/>
+                    <a:p>
+                      <a:pPr>
+                        <a:buNone/>
+                      </a:pPr>
+                      <a:endParaRPr lang="fr-FR"/>
+                    </a:p>
+                  </a:txBody>
+                  <a:tcPr anchor="ctr">
+                    <a:lnL>
+                      <a:noFill/>
+                    </a:lnL>
+                    <a:lnR>
+                      <a:noFill/>
+                    </a:lnR>
+                    <a:lnT>
+                      <a:noFill/>
+                    </a:lnT>
+                    <a:lnB>
+                      <a:noFill/>
+                    </a:lnB>
+                    <a:noFill/>
+                  </a:tcPr>
+                </a:tc>
+                <a:tc>
+                  <a:txBody>
+                    <a:bodyPr/>
+                    <a:lstStyle/>
+                    <a:p>
+                      <a:pPr>
+                        <a:buNone/>
+                      </a:pPr>
+                      <a:endParaRPr lang="fr-FR"/>
+                    </a:p>
+                  </a:txBody>
+                  <a:tcPr anchor="ctr">
+                    <a:lnL>
+                      <a:noFill/>
+                    </a:lnL>
+                    <a:lnR>
+                      <a:noFill/>
+                    </a:lnR>
+                    <a:lnT>
+                      <a:noFill/>
+                    </a:lnT>
+                    <a:lnB>
+                      <a:noFill/>
+                    </a:lnB>
+                    <a:noFill/>
+                  </a:tcPr>
+                </a:tc>
+                <a:extLst>
+                  <a:ext uri="{0D108BD9-81ED-4DB2-BD59-A6C34878D82A}">
+                    <a16:rowId xmlns:a16="http://schemas.microsoft.com/office/drawing/2014/main" val="3792407636"/>
+                  </a:ext>
+                </a:extLst>
+              </a:tr>
+              <a:tr h="0">
+                <a:tc>
+                  <a:txBody>
+                    <a:bodyPr/>
+                    <a:lstStyle/>
+                    <a:p>
+                      <a:pPr>
+                        <a:buNone/>
+                      </a:pPr>
+                      <a:endParaRPr lang="fr-FR"/>
+                    </a:p>
+                  </a:txBody>
+                  <a:tcPr anchor="ctr">
+                    <a:lnL>
+                      <a:noFill/>
+                    </a:lnL>
+                    <a:lnR>
+                      <a:noFill/>
+                    </a:lnR>
+                    <a:lnT>
+                      <a:noFill/>
+                    </a:lnT>
+                    <a:lnB>
+                      <a:noFill/>
+                    </a:lnB>
+                    <a:noFill/>
+                  </a:tcPr>
+                </a:tc>
+                <a:tc>
+                  <a:txBody>
+                    <a:bodyPr/>
+                    <a:lstStyle/>
+                    <a:p>
+                      <a:pPr>
+                        <a:buNone/>
+                      </a:pPr>
+                      <a:endParaRPr lang="fr-FR" dirty="0"/>
+                    </a:p>
+                  </a:txBody>
+                  <a:tcPr anchor="ctr">
+                    <a:lnL>
+                      <a:noFill/>
+                    </a:lnL>
+                    <a:lnR>
+                      <a:noFill/>
+                    </a:lnR>
+                    <a:lnT>
+                      <a:noFill/>
+                    </a:lnT>
+                    <a:lnB>
+                      <a:noFill/>
+                    </a:lnB>
+                    <a:noFill/>
+                  </a:tcPr>
+                </a:tc>
+                <a:extLst>
+                  <a:ext uri="{0D108BD9-81ED-4DB2-BD59-A6C34878D82A}">
+                    <a16:rowId xmlns:a16="http://schemas.microsoft.com/office/drawing/2014/main" val="4286157201"/>
+                  </a:ext>
+                </a:extLst>
+              </a:tr>
+            </a:tbl>
+          </a:graphicData>
+        </a:graphic>
+      </p:graphicFrame>
+      <p:graphicFrame>
+        <p:nvGraphicFramePr>
+          <p:cNvPr id="4" name="Table 3">
+            <a:extLst>
+              <a:ext uri="{FF2B5EF4-FFF2-40B4-BE49-F238E27FC236}">
+                <a16:creationId xmlns:a16="http://schemas.microsoft.com/office/drawing/2014/main" id="{10B8594E-D47D-1F71-6B64-4F803B9BAD47}"/>
+              </a:ext>
+            </a:extLst>
+          </p:cNvPr>
+          <p:cNvGraphicFramePr>
+            <a:graphicFrameLocks noGrp="1"/>
+          </p:cNvGraphicFramePr>
+          <p:nvPr>
+            <p:extLst>
+              <p:ext uri="{D42A27DB-BD31-4B8C-83A1-F6EECF244321}">
+                <p14:modId xmlns:p14="http://schemas.microsoft.com/office/powerpoint/2010/main" val="1430492577"/>
+              </p:ext>
+            </p:extLst>
+          </p:nvPr>
+        </p:nvGraphicFramePr>
+        <p:xfrm>
+          <a:off x="1387531" y="1384616"/>
+          <a:ext cx="6096000" cy="1483360"/>
+        </p:xfrm>
+        <a:graphic>
+          <a:graphicData uri="http://schemas.openxmlformats.org/drawingml/2006/table">
+            <a:tbl>
+              <a:tblPr firstRow="1" bandRow="1">
+                <a:tableStyleId>{5E861988-5A92-4821-BE25-C1E3E971F38B}</a:tableStyleId>
+              </a:tblPr>
+              <a:tblGrid>
+                <a:gridCol w="3048000">
+                  <a:extLst>
+                    <a:ext uri="{9D8B030D-6E8A-4147-A177-3AD203B41FA5}">
+                      <a16:colId xmlns:a16="http://schemas.microsoft.com/office/drawing/2014/main" val="2314172793"/>
+                    </a:ext>
+                  </a:extLst>
+                </a:gridCol>
+                <a:gridCol w="3048000">
+                  <a:extLst>
+                    <a:ext uri="{9D8B030D-6E8A-4147-A177-3AD203B41FA5}">
+                      <a16:colId xmlns:a16="http://schemas.microsoft.com/office/drawing/2014/main" val="3039958710"/>
+                    </a:ext>
+                  </a:extLst>
+                </a:gridCol>
+              </a:tblGrid>
+              <a:tr h="370840">
+                <a:tc>
+                  <a:txBody>
+                    <a:bodyPr/>
+                    <a:lstStyle/>
+                    <a:p>
+                      <a:pPr>
+                        <a:buNone/>
+                      </a:pPr>
+                      <a:r>
+                        <a:rPr lang="fr-FR" dirty="0" err="1"/>
+                        <a:t>Before</a:t>
+                      </a:r>
+                      <a:endParaRPr lang="fr-FR" dirty="0"/>
+                    </a:p>
+                  </a:txBody>
+                  <a:tcPr anchor="ctr"/>
+                </a:tc>
+                <a:tc>
+                  <a:txBody>
+                    <a:bodyPr/>
+                    <a:lstStyle/>
+                    <a:p>
+                      <a:pPr>
+                        <a:buNone/>
+                      </a:pPr>
+                      <a:r>
+                        <a:rPr lang="fr-FR"/>
+                        <a:t>After</a:t>
+                      </a:r>
+                    </a:p>
+                  </a:txBody>
+                  <a:tcPr anchor="ctr"/>
+                </a:tc>
+                <a:extLst>
+                  <a:ext uri="{0D108BD9-81ED-4DB2-BD59-A6C34878D82A}">
+                    <a16:rowId xmlns:a16="http://schemas.microsoft.com/office/drawing/2014/main" val="2503469832"/>
+                  </a:ext>
+                </a:extLst>
+              </a:tr>
+              <a:tr h="370840">
+                <a:tc>
+                  <a:txBody>
+                    <a:bodyPr/>
+                    <a:lstStyle/>
+                    <a:p>
+                      <a:pPr>
+                        <a:buNone/>
+                      </a:pPr>
+                      <a:r>
+                        <a:rPr lang="fr-FR"/>
+                        <a:t>32.5 kWh/day</a:t>
+                      </a:r>
+                    </a:p>
+                  </a:txBody>
+                  <a:tcPr anchor="ctr"/>
+                </a:tc>
+                <a:tc>
+                  <a:txBody>
+                    <a:bodyPr/>
+                    <a:lstStyle/>
+                    <a:p>
+                      <a:pPr>
+                        <a:buNone/>
+                      </a:pPr>
+                      <a:r>
+                        <a:rPr lang="fr-FR" b="1"/>
+                        <a:t>34.0 kWh/day</a:t>
+                      </a:r>
+                      <a:endParaRPr lang="fr-FR"/>
+                    </a:p>
+                  </a:txBody>
+                  <a:tcPr anchor="ctr"/>
+                </a:tc>
+                <a:extLst>
+                  <a:ext uri="{0D108BD9-81ED-4DB2-BD59-A6C34878D82A}">
+                    <a16:rowId xmlns:a16="http://schemas.microsoft.com/office/drawing/2014/main" val="3406457370"/>
+                  </a:ext>
+                </a:extLst>
+              </a:tr>
+              <a:tr h="370840">
+                <a:tc>
+                  <a:txBody>
+                    <a:bodyPr/>
+                    <a:lstStyle/>
+                    <a:p>
+                      <a:pPr>
+                        <a:buNone/>
+                      </a:pPr>
+                      <a:r>
+                        <a:rPr lang="fr-FR"/>
+                        <a:t>17 panels</a:t>
+                      </a:r>
+                    </a:p>
+                  </a:txBody>
+                  <a:tcPr anchor="ctr"/>
+                </a:tc>
+                <a:tc>
+                  <a:txBody>
+                    <a:bodyPr/>
+                    <a:lstStyle/>
+                    <a:p>
+                      <a:pPr>
+                        <a:buNone/>
+                      </a:pPr>
+                      <a:r>
+                        <a:rPr lang="fr-FR" b="1"/>
+                        <a:t>18 panels</a:t>
+                      </a:r>
+                      <a:endParaRPr lang="fr-FR"/>
+                    </a:p>
+                  </a:txBody>
+                  <a:tcPr anchor="ctr"/>
+                </a:tc>
+                <a:extLst>
+                  <a:ext uri="{0D108BD9-81ED-4DB2-BD59-A6C34878D82A}">
+                    <a16:rowId xmlns:a16="http://schemas.microsoft.com/office/drawing/2014/main" val="2101487634"/>
+                  </a:ext>
+                </a:extLst>
+              </a:tr>
+              <a:tr h="370840">
+                <a:tc>
+                  <a:txBody>
+                    <a:bodyPr/>
+                    <a:lstStyle/>
+                    <a:p>
+                      <a:pPr>
+                        <a:buNone/>
+                      </a:pPr>
+                      <a:r>
+                        <a:rPr lang="fr-FR"/>
+                        <a:t>71.8% CO₂ reduction</a:t>
+                      </a:r>
+                    </a:p>
+                  </a:txBody>
+                  <a:tcPr anchor="ctr"/>
+                </a:tc>
+                <a:tc>
+                  <a:txBody>
+                    <a:bodyPr/>
+                    <a:lstStyle/>
+                    <a:p>
+                      <a:pPr>
+                        <a:buNone/>
+                      </a:pPr>
+                      <a:r>
+                        <a:rPr lang="fr-FR" b="1" dirty="0"/>
+                        <a:t>72.6% CO₂ </a:t>
+                      </a:r>
+                      <a:r>
+                        <a:rPr lang="fr-FR" b="1" dirty="0" err="1"/>
+                        <a:t>reduction</a:t>
+                      </a:r>
+                      <a:endParaRPr lang="fr-FR" dirty="0"/>
+                    </a:p>
+                  </a:txBody>
+                  <a:tcPr anchor="ctr"/>
+                </a:tc>
+                <a:extLst>
+                  <a:ext uri="{0D108BD9-81ED-4DB2-BD59-A6C34878D82A}">
+                    <a16:rowId xmlns:a16="http://schemas.microsoft.com/office/drawing/2014/main" val="749311311"/>
+                  </a:ext>
+                </a:extLst>
+              </a:tr>
+            </a:tbl>
+          </a:graphicData>
+        </a:graphic>
+      </p:graphicFrame>
+    </p:spTree>
+    <p:extLst>
+      <p:ext uri="{BB962C8B-B14F-4D97-AF65-F5344CB8AC3E}">
+        <p14:creationId xmlns:p14="http://schemas.microsoft.com/office/powerpoint/2010/main" val="3602197724"/>
+      </p:ext>
+    </p:extLst>
+  </p:cSld>
+  <p:clrMapOvr>
+    <a:masterClrMapping/>
+  </p:clrMapOvr>
+</p:sld>
+</file>
+
+<file path=ppt/slides/slide16.xml><?xml version="1.0" encoding="utf-8"?>
+<p:sld xmlns:a="http://schemas.openxmlformats.org/drawingml/2006/main" xmlns:r="http://schemas.openxmlformats.org/officeDocument/2006/relationships" xmlns:p="http://schemas.openxmlformats.org/presentationml/2006/main">
+  <p:cSld>
+    <p:spTree>
+      <p:nvGrpSpPr>
         <p:cNvPr id="1" name="Shape 588"/>
         <p:cNvGrpSpPr/>
         <p:nvPr/>
@@ -23143,120 +27766,8 @@
               <a:buChar char="§"/>
             </a:pPr>
             <a:r>
-              <a:rPr lang="en" dirty="0"/>
-              <a:t>Distance betwee</a:t>
-            </a:r>
-            <a:r>
-              <a:rPr lang="fr-FR" dirty="0" err="1"/>
-              <a:t>Confirm</a:t>
-            </a:r>
-            <a:r>
-              <a:rPr lang="fr-FR" dirty="0"/>
-              <a:t> the ROI </a:t>
-            </a:r>
-            <a:r>
-              <a:rPr lang="fr-FR" dirty="0" err="1"/>
-              <a:t>reference</a:t>
-            </a:r>
-            <a:r>
-              <a:rPr lang="fr-FR" dirty="0"/>
-              <a:t> </a:t>
-            </a:r>
-            <a:r>
-              <a:rPr lang="fr-FR" dirty="0" err="1"/>
-              <a:t>price</a:t>
-            </a:r>
-            <a:r>
-              <a:rPr lang="fr-FR" dirty="0"/>
-              <a:t> (</a:t>
-            </a:r>
-            <a:r>
-              <a:rPr lang="fr-FR" dirty="0" err="1"/>
-              <a:t>avoided</a:t>
-            </a:r>
-            <a:r>
-              <a:rPr lang="fr-FR" dirty="0"/>
-              <a:t> diesel vs. </a:t>
-            </a:r>
-            <a:r>
-              <a:rPr lang="fr-FR" dirty="0" err="1"/>
-              <a:t>grid</a:t>
-            </a:r>
-            <a:r>
-              <a:rPr lang="fr-FR" dirty="0"/>
-              <a:t> </a:t>
-            </a:r>
-            <a:r>
-              <a:rPr lang="fr-FR" dirty="0" err="1"/>
-              <a:t>tariff</a:t>
-            </a:r>
-            <a:r>
-              <a:rPr lang="fr-FR" dirty="0"/>
-              <a:t>)</a:t>
-            </a:r>
-          </a:p>
-          <a:p>
-            <a:pPr marL="171450" lvl="0" indent="-171450">
-              <a:buFont typeface="Wingdings" panose="05000000000000000000" pitchFamily="2" charset="2"/>
-              <a:buChar char="§"/>
-            </a:pPr>
-            <a:r>
-              <a:rPr lang="fr-FR" dirty="0" err="1"/>
-              <a:t>Validate</a:t>
-            </a:r>
-            <a:r>
-              <a:rPr lang="fr-FR" dirty="0"/>
-              <a:t> the </a:t>
-            </a:r>
-            <a:r>
-              <a:rPr lang="fr-FR" dirty="0" err="1"/>
-              <a:t>inverter</a:t>
-            </a:r>
-            <a:r>
-              <a:rPr lang="fr-FR" dirty="0"/>
-              <a:t> </a:t>
-            </a:r>
-            <a:r>
-              <a:rPr lang="fr-FR" dirty="0" err="1"/>
-              <a:t>sizing</a:t>
-            </a:r>
-            <a:r>
-              <a:rPr lang="fr-FR" dirty="0"/>
-              <a:t> </a:t>
-            </a:r>
-          </a:p>
-          <a:p>
-            <a:pPr marL="171450" lvl="0" indent="-171450">
-              <a:buFont typeface="Wingdings" panose="05000000000000000000" pitchFamily="2" charset="2"/>
-              <a:buChar char="§"/>
-            </a:pPr>
-            <a:r>
-              <a:rPr lang="fr-FR" dirty="0" err="1"/>
-              <a:t>Decide</a:t>
-            </a:r>
-            <a:r>
-              <a:rPr lang="fr-FR" dirty="0"/>
-              <a:t> </a:t>
-            </a:r>
-            <a:r>
-              <a:rPr lang="fr-FR" dirty="0" err="1"/>
-              <a:t>between</a:t>
-            </a:r>
-            <a:r>
-              <a:rPr lang="fr-FR" dirty="0"/>
-              <a:t> </a:t>
-            </a:r>
-            <a:r>
-              <a:rPr lang="fr-FR" dirty="0" err="1"/>
-              <a:t>monocrystalline</a:t>
-            </a:r>
-            <a:r>
-              <a:rPr lang="fr-FR" dirty="0"/>
-              <a:t> vs. </a:t>
-            </a:r>
-            <a:r>
-              <a:rPr lang="fr-FR" dirty="0" err="1"/>
-              <a:t>polycrystalline</a:t>
+              <a:rPr lang="en-US" dirty="0"/>
+              <a:t>To clarify: Is the mango washing/cutting pump separate from the irrigation pump or already included in the 7.5 kWh/day?</a:t>
             </a:r>
             <a:endParaRPr lang="fr-FR" dirty="0"/>
           </a:p>
@@ -23426,7 +27937,7 @@
 </p:sld>
 </file>
 
-<file path=ppt/slides/slide15.xml><?xml version="1.0" encoding="utf-8"?>
+<file path=ppt/slides/slide17.xml><?xml version="1.0" encoding="utf-8"?>
 <p:sld xmlns:a="http://schemas.openxmlformats.org/drawingml/2006/main" xmlns:r="http://schemas.openxmlformats.org/officeDocument/2006/relationships" xmlns:p="http://schemas.openxmlformats.org/presentationml/2006/main">
   <p:cSld>
     <p:spTree>

</xml_diff>